<commit_message>
docs: add 4-tier OLAM architecture diagram, star schema diagram, and 2-member workload division to slides, web app and report
</commit_message>
<xml_diff>
--- a/slides/presentation.pptx
+++ b/slides/presentation.pptx
@@ -19,6 +19,8 @@
     <p:sldId id="267" r:id="rId19"/>
     <p:sldId id="268" r:id="rId20"/>
     <p:sldId id="269" r:id="rId21"/>
+    <p:sldId id="270" r:id="rId22"/>
+    <p:sldId id="271" r:id="rId23"/>
   </p:sldIdLst>
   <p:sldSz cx="12191695" cy="6858000" type="screen4x3"/>
   <p:notesSz cx="6858000" cy="9144000"/>
@@ -585,7 +587,7 @@
           <a:lstStyle/>
           <a:p>
             <a:r>
-              <a:t>Đối với câu hỏi Q2, chúng em huấn luyện mô hình Lọc cộng tác Item-Based trên ma trận Cosine thưa. Tập kiểm thử được tách theo thời gian 80/20 để đảm bảo tính khách quan tuyệt đối.</a:t>
+              <a:t>Để trả lời Q1, chúng em phân cụm 6,040 người dùng thành 4 phân khúc gu điện ảnh rõ nét. Biểu đồ PCA bên phải thể hiện sự phân tách rõ ràng của 4 cụm trên không gian giảm chiều với tâm cụm đánh dấu chữ X đỏ.</a:t>
             </a:r>
           </a:p>
         </p:txBody>
@@ -655,7 +657,7 @@
           <a:lstStyle/>
           <a:p>
             <a:r>
-              <a:t>Trả lời câu hỏi Q2: Khai phá FP-Growth trên các giao dịch rating &gt;= 4 phát hiện những luật kết hợp rất giá trị. Khán giả thích James Cameron có độ tin cậy tới 23.8% sẽ thích Predator. Đặc biệt người thích John Woo có độ nâng Lift trên 5.0 với các phim hành động phong cách cùng thời như Snake Eyes, Eraser.</a:t>
+              <a:t>Kiểm định Chi-Square chứng minh bằng toán học với p &lt; 0.001: Sự khác biệt thị hiếu giữa các nhóm tuổi và giới tính không phải ngẫu nhiên mà là quy luật thực tế. Nam thanh niên yêu thích Hành động/Sci-Fi; Nữ và trẻ em thiên về Hài/Gia đình; người lớn tuổi gắn bó với Tâm lý.</a:t>
             </a:r>
           </a:p>
         </p:txBody>
@@ -725,7 +727,7 @@
           <a:lstStyle/>
           <a:p>
             <a:r>
-              <a:t>Chúng em đã xây dựng sẵn 4 SQL views và tài liệu hướng dẫn docs/powerbi_guide.md gồm đầy đủ công thức DAX để triển khai 4 trang Dashboard quản trị doanh nghiệp chuyên nghiệp trên Power BI Desktop.</a:t>
+              <a:t>Đối với câu hỏi Q2, chúng em huấn luyện mô hình Lọc cộng tác Item-Based trên ma trận Cosine thưa. Tập kiểm thử được tách theo thời gian 80/20 để đảm bảo tính khách quan tuyệt đối.</a:t>
             </a:r>
           </a:p>
         </p:txBody>
@@ -795,7 +797,7 @@
           <a:lstStyle/>
           <a:p>
             <a:r>
-              <a:t>Từ kết quả phân tích dữ liệu thực nghiệm, nhóm đưa ra 3 khuyến nghị chiến lược có số liệu bảo chứng rõ ràng giúp nền tảng tối ưu hóa danh mục nội dung và tăng cường giữ chân người dùng.</a:t>
+              <a:t>Trả lời câu hỏi Q2: Khai phá FP-Growth trên các giao dịch rating &gt;= 4 phát hiện những luật kết hợp rất giá trị. Khán giả thích James Cameron có độ tin cậy tới 23.8% sẽ thích Predator. Đặc biệt người thích John Woo có độ nâng Lift trên 5.0 với các phim hành động phong cách cùng thời như Snake Eyes, Eraser.</a:t>
             </a:r>
           </a:p>
         </p:txBody>
@@ -865,6 +867,146 @@
           <a:lstStyle/>
           <a:p>
             <a:r>
+              <a:t>Chúng em đã xây dựng sẵn 4 SQL views và tài liệu hướng dẫn docs/powerbi_guide.md gồm đầy đủ công thức DAX để triển khai 4 trang Dashboard quản trị doanh nghiệp chuyên nghiệp trên Power BI Desktop.</a:t>
+            </a:r>
+          </a:p>
+        </p:txBody>
+      </p:sp>
+      <p:sp>
+        <p:nvSpPr>
+          <p:cNvPr id="4" name="Slide Number Placeholder 3"/>
+          <p:cNvSpPr>
+            <a:spLocks noGrp="1"/>
+          </p:cNvSpPr>
+          <p:nvPr>
+            <p:ph type="sldNum" idx="5" sz="quarter"/>
+          </p:nvPr>
+        </p:nvSpPr>
+        <p:spPr/>
+      </p:sp>
+    </p:spTree>
+  </p:cSld>
+  <p:clrMapOvr>
+    <a:masterClrMapping/>
+  </p:clrMapOvr>
+</p:notes>
+</file>
+
+<file path=ppt/notesSlides/notesSlide15.xml><?xml version="1.0" encoding="utf-8"?>
+<p:notes xmlns:a="http://schemas.openxmlformats.org/drawingml/2006/main" xmlns:p="http://schemas.openxmlformats.org/presentationml/2006/main" xmlns:r="http://schemas.openxmlformats.org/officeDocument/2006/relationships">
+  <p:cSld>
+    <p:spTree>
+      <p:nvGrpSpPr>
+        <p:cNvPr id="1" name=""/>
+        <p:cNvGrpSpPr/>
+        <p:nvPr/>
+      </p:nvGrpSpPr>
+      <p:grpSpPr>
+        <a:xfrm>
+          <a:off x="0" y="0"/>
+          <a:ext cx="0" cy="0"/>
+          <a:chOff x="0" y="0"/>
+          <a:chExt cx="0" cy="0"/>
+        </a:xfrm>
+      </p:grpSpPr>
+      <p:sp>
+        <p:nvSpPr>
+          <p:cNvPr id="2" name="Slide Image Placeholder 1"/>
+          <p:cNvSpPr>
+            <a:spLocks noGrp="1"/>
+          </p:cNvSpPr>
+          <p:nvPr>
+            <p:ph type="sldImg" idx="2"/>
+          </p:nvPr>
+        </p:nvSpPr>
+        <p:spPr/>
+      </p:sp>
+      <p:sp>
+        <p:nvSpPr>
+          <p:cNvPr id="3" name="Notes Placeholder 2"/>
+          <p:cNvSpPr>
+            <a:spLocks noGrp="1"/>
+          </p:cNvSpPr>
+          <p:nvPr>
+            <p:ph type="body" idx="3" sz="quarter"/>
+          </p:nvPr>
+        </p:nvSpPr>
+        <p:spPr/>
+        <p:txBody>
+          <a:bodyPr/>
+          <a:lstStyle/>
+          <a:p>
+            <a:r>
+              <a:t>Từ kết quả phân tích dữ liệu thực nghiệm, nhóm đưa ra 3 khuyến nghị chiến lược có số liệu bảo chứng rõ ràng giúp nền tảng tối ưu hóa danh mục nội dung và tăng cường giữ chân người dùng.</a:t>
+            </a:r>
+          </a:p>
+        </p:txBody>
+      </p:sp>
+      <p:sp>
+        <p:nvSpPr>
+          <p:cNvPr id="4" name="Slide Number Placeholder 3"/>
+          <p:cNvSpPr>
+            <a:spLocks noGrp="1"/>
+          </p:cNvSpPr>
+          <p:nvPr>
+            <p:ph type="sldNum" idx="5" sz="quarter"/>
+          </p:nvPr>
+        </p:nvSpPr>
+        <p:spPr/>
+      </p:sp>
+    </p:spTree>
+  </p:cSld>
+  <p:clrMapOvr>
+    <a:masterClrMapping/>
+  </p:clrMapOvr>
+</p:notes>
+</file>
+
+<file path=ppt/notesSlides/notesSlide16.xml><?xml version="1.0" encoding="utf-8"?>
+<p:notes xmlns:a="http://schemas.openxmlformats.org/drawingml/2006/main" xmlns:p="http://schemas.openxmlformats.org/presentationml/2006/main" xmlns:r="http://schemas.openxmlformats.org/officeDocument/2006/relationships">
+  <p:cSld>
+    <p:spTree>
+      <p:nvGrpSpPr>
+        <p:cNvPr id="1" name=""/>
+        <p:cNvGrpSpPr/>
+        <p:nvPr/>
+      </p:nvGrpSpPr>
+      <p:grpSpPr>
+        <a:xfrm>
+          <a:off x="0" y="0"/>
+          <a:ext cx="0" cy="0"/>
+          <a:chOff x="0" y="0"/>
+          <a:chExt cx="0" cy="0"/>
+        </a:xfrm>
+      </p:grpSpPr>
+      <p:sp>
+        <p:nvSpPr>
+          <p:cNvPr id="2" name="Slide Image Placeholder 1"/>
+          <p:cNvSpPr>
+            <a:spLocks noGrp="1"/>
+          </p:cNvSpPr>
+          <p:nvPr>
+            <p:ph type="sldImg" idx="2"/>
+          </p:nvPr>
+        </p:nvSpPr>
+        <p:spPr/>
+      </p:sp>
+      <p:sp>
+        <p:nvSpPr>
+          <p:cNvPr id="3" name="Notes Placeholder 2"/>
+          <p:cNvSpPr>
+            <a:spLocks noGrp="1"/>
+          </p:cNvSpPr>
+          <p:nvPr>
+            <p:ph type="body" idx="3" sz="quarter"/>
+          </p:nvPr>
+        </p:nvSpPr>
+        <p:spPr/>
+        <p:txBody>
+          <a:bodyPr/>
+          <a:lstStyle/>
+          <a:p>
+            <a:r>
               <a:t>Em xin kết thúc bài báo cáo tại đây. Cảm ơn quý Thầy Cô đã theo dõi, nhóm em xin sẵn sàng tiếp nhận các câu hỏi phản biện từ Hội đồng chấm thi ạ!</a:t>
             </a:r>
           </a:p>
@@ -935,7 +1077,7 @@
           <a:lstStyle/>
           <a:p>
             <a:r>
-              <a:t>Đề tài giải quyết trọn vẹn 3 câu hỏi nghiệp vụ thực tế của một nền tảng SVoD: Q1 giúp thấu hiểu cấu trúc khách hàng qua nhân khẩu học; Q2 xây dựng công cụ gợi ý cá nhân hóa và luật kết hợp đạo diễn; Q3 cung cấp bức tranh tăng trưởng vĩ mô theo quý để lãnh đạo ra quyết định mua bản quyền.</a:t>
+              <a:t>Về phân chia công việc trong nhóm: Để đảm bảo tính chuyên môn hóa và hiệu quả cao nhất, nhóm phân định rõ 2 vai trò: Thành viên 1 đảm nhiệm vai trò Data Engineer phụ trách toàn bộ hạ tầng kho dữ liệu SQL Server, quy trình ETL, kiểm toán chất lượng và OLAP. Thành viên 2 đảm nhiệm vai trò Data Scientist &amp; BI phụ trách trích xuất đặc trưng, thuật toán K-Means, Lọc cộng tác, Luật kết hợp FP-Growth và giao diện Web App Streamlit. Cả hai thành viên đóng góp đồng đều 50% khối lượng công việc và phối hợp chặt chẽ trong suốt 9 giai đoạn của đề tài.</a:t>
             </a:r>
           </a:p>
         </p:txBody>
@@ -1005,7 +1147,7 @@
           <a:lstStyle/>
           <a:p>
             <a:r>
-              <a:t>Chúng em tích hợp 3 nguồn dữ liệu: MovieLens 1M làm nòng cốt, IMDb làm giàu thông tin đạo diễn với tỷ lệ khớp đạt 88.23%, và Netflix titles làm thước đo đối sánh thị trường. Cột thời gian xem được mô phỏng khoa học và gắn cờ minh bạch.</a:t>
+              <a:t>Đề tài giải quyết trọn vẹn 3 câu hỏi nghiệp vụ thực tế của một nền tảng SVoD: Q1 giúp thấu hiểu cấu trúc khách hàng qua nhân khẩu học; Q2 xây dựng công cụ gợi ý cá nhân hóa và luật kết hợp đạo diễn; Q3 cung cấp bức tranh tăng trưởng vĩ mô theo quý để lãnh đạo ra quyết định mua bản quyền.</a:t>
             </a:r>
           </a:p>
         </p:txBody>
@@ -1075,7 +1217,7 @@
           <a:lstStyle/>
           <a:p>
             <a:r>
-              <a:t>Kho dữ liệu được tổ chức theo chuẩn Star Schema mở rộng. Bảng FactRating ở trung tâm liên kết 5 bảng chiều qua các Surrogate Key. Mối quan hệ N-N giữa Phim và Thể loại được giải quyết chuẩn mực bằng BridgeMovieGenre.</a:t>
+              <a:t>Kiến trúc hệ thống được thiết kế theo chuẩn 4 tầng OLAM (On-Line Analytical Mining) theo giáo trình môn học: Dữ liệu từ 3 nguồn được ETL nạp vào Kho dữ liệu SQL Server tầng 2; sau đó Tầng 3 thực thi song song các phân tích OLAP và mô hình khai phá dữ liệu; cuối cùng kết quả được hiển thị trực quan lên Web App Streamlit và Dashboard Power BI ở Tầng 4.</a:t>
             </a:r>
           </a:p>
         </p:txBody>
@@ -1145,7 +1287,7 @@
           <a:lstStyle/>
           <a:p>
             <a:r>
-              <a:t>Pipeline ETL được viết bằng Python kết hợp T-SQL batching. Ngay sau khi nạp, hệ thống kích hoạt bộ kiểm toán tự động và vượt qua 5/5 bài kiểm tra với độ tin cậy 100%, bảo đảm không có dữ liệu rác hay khóa mồ côi trước khi khai phá.</a:t>
+              <a:t>Kho dữ liệu được tổ chức theo chuẩn Star Schema mở rộng. Bảng FactRating ở trung tâm liên kết 5 bảng chiều qua các Surrogate Key. Mối quan hệ N-N giữa Phim và Thể loại được giải quyết chuẩn mực bằng BridgeMovieGenre.</a:t>
             </a:r>
           </a:p>
         </p:txBody>
@@ -1215,7 +1357,7 @@
           <a:lstStyle/>
           <a:p>
             <a:r>
-              <a:t>Trả lời câu hỏi Q3: Trong các quý gần đây, thể loại Sci-Fi có tốc độ tăng trưởng mạnh nhất đạt +17.02% QoQ, theo sát là Documentary đạt +15.09%. Biểu đồ bên phải thể hiện rõ chuỗi biến động QoQ của 6 thể loại chính qua các năm.</a:t>
+              <a:t>Chúng em tích hợp 3 nguồn dữ liệu: MovieLens 1M làm nòng cốt, IMDb làm giàu thông tin đạo diễn với tỷ lệ khớp đạt 88.23%, và Netflix titles làm thước đo đối sánh thị trường. Cột thời gian xem được mô phỏng khoa học và gắn cờ minh bạch.</a:t>
             </a:r>
           </a:p>
         </p:txBody>
@@ -1285,7 +1427,7 @@
           <a:lstStyle/>
           <a:p>
             <a:r>
-              <a:t>Chúng em đã triển khai đầy đủ cả 5 phép toán OLAP kinh điển trong file 04_olap_queries.sql: Roll-up, Drill-down, Slice, Dice và Pivot, bám sát từng ví dụ trong chương 3 của giáo trình.</a:t>
+              <a:t>Pipeline ETL được viết bằng Python kết hợp T-SQL batching. Ngay sau khi nạp, hệ thống kích hoạt bộ kiểm toán tự động và vượt qua 5/5 bài kiểm tra với độ tin cậy 100%, bảo đảm không có dữ liệu rác hay khóa mồ côi trước khi khai phá.</a:t>
             </a:r>
           </a:p>
         </p:txBody>
@@ -1355,7 +1497,7 @@
           <a:lstStyle/>
           <a:p>
             <a:r>
-              <a:t>Để trả lời Q1, chúng em phân cụm 6,040 người dùng thành 4 phân khúc gu điện ảnh rõ nét. Biểu đồ PCA bên phải thể hiện sự phân tách rõ ràng của 4 cụm trên không gian giảm chiều với tâm cụm đánh dấu chữ X đỏ.</a:t>
+              <a:t>Trả lời câu hỏi Q3: Trong các quý gần đây, thể loại Sci-Fi có tốc độ tăng trưởng mạnh nhất đạt +17.02% QoQ, theo sát là Documentary đạt +15.09%. Biểu đồ bên phải thể hiện rõ chuỗi biến động QoQ của 6 thể loại chính qua các năm.</a:t>
             </a:r>
           </a:p>
         </p:txBody>
@@ -1425,7 +1567,7 @@
           <a:lstStyle/>
           <a:p>
             <a:r>
-              <a:t>Kiểm định Chi-Square chứng minh bằng toán học với p &lt; 0.001: Sự khác biệt thị hiếu giữa các nhóm tuổi và giới tính không phải ngẫu nhiên mà là quy luật thực tế. Nam thanh niên yêu thích Hành động/Sci-Fi; Nữ và trẻ em thiên về Hài/Gia đình; người lớn tuổi gắn bó với Tâm lý.</a:t>
+              <a:t>Chúng em đã triển khai đầy đủ cả 5 phép toán OLAP kinh điển trong file 04_olap_queries.sql: Roll-up, Drill-down, Slice, Dice và Pivot, bám sát từng ví dụ trong chương 3 của giáo trình.</a:t>
             </a:r>
           </a:p>
         </p:txBody>
@@ -4637,6 +4779,554 @@
               </a:defRPr>
             </a:pPr>
             <a:r>
+              <a:t>Khai Phá Phân Cụm Người Dùng Bằng K-Means &amp; PCA (Q1)</a:t>
+            </a:r>
+          </a:p>
+        </p:txBody>
+      </p:sp>
+      <p:sp>
+        <p:nvSpPr>
+          <p:cNvPr id="4" name="Rounded Rectangle 3"/>
+          <p:cNvSpPr/>
+          <p:nvPr/>
+        </p:nvSpPr>
+        <p:spPr>
+          <a:xfrm>
+            <a:off x="731520" y="1645920"/>
+            <a:ext cx="4937760" cy="4389120"/>
+          </a:xfrm>
+          <a:prstGeom prst="roundRect">
+            <a:avLst/>
+          </a:prstGeom>
+          <a:solidFill>
+            <a:srgbClr val="F8FAFC"/>
+          </a:solidFill>
+          <a:ln w="12700">
+            <a:solidFill>
+              <a:srgbClr val="E2E8F0"/>
+            </a:solidFill>
+          </a:ln>
+        </p:spPr>
+        <p:style>
+          <a:lnRef idx="1">
+            <a:schemeClr val="accent1"/>
+          </a:lnRef>
+          <a:fillRef idx="3">
+            <a:schemeClr val="accent1"/>
+          </a:fillRef>
+          <a:effectRef idx="2">
+            <a:schemeClr val="accent1"/>
+          </a:effectRef>
+          <a:fontRef idx="minor">
+            <a:schemeClr val="lt1"/>
+          </a:fontRef>
+        </p:style>
+        <p:txBody>
+          <a:bodyPr rtlCol="0" anchor="ctr" wrap="square" lIns="182880" rIns="182880" tIns="182880" bIns="182880"/>
+          <a:lstStyle/>
+          <a:p>
+            <a:pPr algn="ctr">
+              <a:spcAft>
+                <a:spcPts val="600"/>
+              </a:spcAft>
+              <a:defRPr sz="1300" b="1">
+                <a:solidFill>
+                  <a:srgbClr val="1E3A8A"/>
+                </a:solidFill>
+              </a:defRPr>
+            </a:pPr>
+            <a:r>
+              <a:t>👥 Chân Dung 4 Cụm Thị Hiếu Khán GiẢ</a:t>
+            </a:r>
+          </a:p>
+          <a:p>
+            <a:pPr>
+              <a:spcAft>
+                <a:spcPts val="400"/>
+              </a:spcAft>
+              <a:defRPr sz="1050">
+                <a:solidFill>
+                  <a:srgbClr val="0F172A"/>
+                </a:solidFill>
+              </a:defRPr>
+            </a:pPr>
+            <a:r>
+              <a:t>• Xác định K=4 tối ưu qua Elbow (SSE) &amp; Silhouette.</a:t>
+            </a:r>
+          </a:p>
+          <a:p>
+            <a:pPr>
+              <a:spcAft>
+                <a:spcPts val="400"/>
+              </a:spcAft>
+              <a:defRPr sz="1050">
+                <a:solidFill>
+                  <a:srgbClr val="0F172A"/>
+                </a:solidFill>
+              </a:defRPr>
+            </a:pPr>
+            <a:r>
+              <a:t>• Cụm 0 (26.1% - 1,579 users): Tín đồ Hành động &amp; Sci-Fi (Action 18.3%, Sci-Fi 12.6%).</a:t>
+            </a:r>
+          </a:p>
+          <a:p>
+            <a:pPr>
+              <a:spcAft>
+                <a:spcPts val="400"/>
+              </a:spcAft>
+              <a:defRPr sz="1050">
+                <a:solidFill>
+                  <a:srgbClr val="0F172A"/>
+                </a:solidFill>
+              </a:defRPr>
+            </a:pPr>
+            <a:r>
+              <a:t>• Cụm 1 (36.0% - 2,177 users): Khán giả Tâm lý &amp; Lãng mạn (Drama 24.0%, Romance 8.7%).</a:t>
+            </a:r>
+          </a:p>
+          <a:p>
+            <a:pPr>
+              <a:spcAft>
+                <a:spcPts val="400"/>
+              </a:spcAft>
+              <a:defRPr sz="1050">
+                <a:solidFill>
+                  <a:srgbClr val="0F172A"/>
+                </a:solidFill>
+              </a:defRPr>
+            </a:pPr>
+            <a:r>
+              <a:t>• Cụm 2 (31.2% - 1,882 users): Khán giả Giải trí Đại chúng (Comedy 18.9%, Drama 18.0%).</a:t>
+            </a:r>
+          </a:p>
+          <a:p>
+            <a:pPr>
+              <a:spcAft>
+                <a:spcPts val="400"/>
+              </a:spcAft>
+              <a:defRPr sz="1050">
+                <a:solidFill>
+                  <a:srgbClr val="0F172A"/>
+                </a:solidFill>
+              </a:defRPr>
+            </a:pPr>
+            <a:r>
+              <a:t>• Cụm 3 (6.7% - 402 users): Khán giả Gia đình &amp; Thiếu nhi (Comedy 19.4%, Children's 11.9%).</a:t>
+            </a:r>
+          </a:p>
+        </p:txBody>
+      </p:sp>
+      <p:pic>
+        <p:nvPicPr>
+          <p:cNvPr id="5" name="Picture 4" descr="kmeans_clusters_pca.png"/>
+          <p:cNvPicPr>
+            <a:picLocks noChangeAspect="1"/>
+          </p:cNvPicPr>
+          <p:nvPr/>
+        </p:nvPicPr>
+        <p:blipFill>
+          <a:blip r:embed="rId2"/>
+          <a:stretch>
+            <a:fillRect/>
+          </a:stretch>
+        </p:blipFill>
+        <p:spPr>
+          <a:xfrm>
+            <a:off x="5943600" y="1645920"/>
+            <a:ext cx="5486400" cy="3840480"/>
+          </a:xfrm>
+          <a:prstGeom prst="rect">
+            <a:avLst/>
+          </a:prstGeom>
+        </p:spPr>
+      </p:pic>
+    </p:spTree>
+  </p:cSld>
+  <p:clrMapOvr>
+    <a:masterClrMapping/>
+  </p:clrMapOvr>
+</p:sld>
+</file>
+
+<file path=ppt/slides/slide11.xml><?xml version="1.0" encoding="utf-8"?>
+<p:sld xmlns:a="http://schemas.openxmlformats.org/drawingml/2006/main" xmlns:p="http://schemas.openxmlformats.org/presentationml/2006/main" xmlns:r="http://schemas.openxmlformats.org/officeDocument/2006/relationships">
+  <p:cSld>
+    <p:spTree>
+      <p:nvGrpSpPr>
+        <p:cNvPr id="1" name=""/>
+        <p:cNvGrpSpPr/>
+        <p:nvPr/>
+      </p:nvGrpSpPr>
+      <p:grpSpPr/>
+      <p:sp>
+        <p:nvSpPr>
+          <p:cNvPr id="2" name="TextBox 1"/>
+          <p:cNvSpPr txBox="1"/>
+          <p:nvPr/>
+        </p:nvSpPr>
+        <p:spPr>
+          <a:xfrm>
+            <a:off x="731520" y="365760"/>
+            <a:ext cx="10058400" cy="274320"/>
+          </a:xfrm>
+          <a:prstGeom prst="rect">
+            <a:avLst/>
+          </a:prstGeom>
+          <a:noFill/>
+        </p:spPr>
+        <p:txBody>
+          <a:bodyPr wrap="square">
+            <a:spAutoFit/>
+          </a:bodyPr>
+          <a:lstStyle/>
+          <a:p>
+            <a:pPr>
+              <a:defRPr sz="900" b="1">
+                <a:solidFill>
+                  <a:srgbClr val="2563EB"/>
+                </a:solidFill>
+              </a:defRPr>
+            </a:pPr>
+            <a:r>
+              <a:t>KHO DỮ LIỆU &amp; KHAI PHÁ DỮ LIỆU • PTIT</a:t>
+            </a:r>
+          </a:p>
+        </p:txBody>
+      </p:sp>
+      <p:sp>
+        <p:nvSpPr>
+          <p:cNvPr id="3" name="TextBox 2"/>
+          <p:cNvSpPr txBox="1"/>
+          <p:nvPr/>
+        </p:nvSpPr>
+        <p:spPr>
+          <a:xfrm>
+            <a:off x="731520" y="594360"/>
+            <a:ext cx="10515600" cy="731520"/>
+          </a:xfrm>
+          <a:prstGeom prst="rect">
+            <a:avLst/>
+          </a:prstGeom>
+          <a:noFill/>
+        </p:spPr>
+        <p:txBody>
+          <a:bodyPr wrap="square">
+            <a:spAutoFit/>
+          </a:bodyPr>
+          <a:lstStyle/>
+          <a:p>
+            <a:pPr>
+              <a:defRPr sz="2200" b="1">
+                <a:solidFill>
+                  <a:srgbClr val="1E3A8A"/>
+                </a:solidFill>
+              </a:defRPr>
+            </a:pPr>
+            <a:r>
+              <a:t>Kiểm Định Thống Kê Chi-Square: Thị Hiếu Theo Tuổi &amp; Giới Tính (Q1)</a:t>
+            </a:r>
+          </a:p>
+        </p:txBody>
+      </p:sp>
+      <p:sp>
+        <p:nvSpPr>
+          <p:cNvPr id="4" name="Rounded Rectangle 3"/>
+          <p:cNvSpPr/>
+          <p:nvPr/>
+        </p:nvSpPr>
+        <p:spPr>
+          <a:xfrm>
+            <a:off x="731520" y="1645920"/>
+            <a:ext cx="4937760" cy="4389120"/>
+          </a:xfrm>
+          <a:prstGeom prst="roundRect">
+            <a:avLst/>
+          </a:prstGeom>
+          <a:solidFill>
+            <a:srgbClr val="F8FAFC"/>
+          </a:solidFill>
+          <a:ln w="12700">
+            <a:solidFill>
+              <a:srgbClr val="E2E8F0"/>
+            </a:solidFill>
+          </a:ln>
+        </p:spPr>
+        <p:style>
+          <a:lnRef idx="1">
+            <a:schemeClr val="accent1"/>
+          </a:lnRef>
+          <a:fillRef idx="3">
+            <a:schemeClr val="accent1"/>
+          </a:fillRef>
+          <a:effectRef idx="2">
+            <a:schemeClr val="accent1"/>
+          </a:effectRef>
+          <a:fontRef idx="minor">
+            <a:schemeClr val="lt1"/>
+          </a:fontRef>
+        </p:style>
+        <p:txBody>
+          <a:bodyPr rtlCol="0" anchor="ctr" wrap="square" lIns="182880" rIns="182880" tIns="182880" bIns="182880"/>
+          <a:lstStyle/>
+          <a:p>
+            <a:pPr algn="ctr">
+              <a:spcAft>
+                <a:spcPts val="600"/>
+              </a:spcAft>
+              <a:defRPr sz="1300" b="1">
+                <a:solidFill>
+                  <a:srgbClr val="1E3A8A"/>
+                </a:solidFill>
+              </a:defRPr>
+            </a:pPr>
+            <a:r>
+              <a:t>🧪 Kết Quả Kiểm Định Chi-Square (p &lt; 0.001)</a:t>
+            </a:r>
+          </a:p>
+          <a:p>
+            <a:pPr>
+              <a:spcAft>
+                <a:spcPts val="400"/>
+              </a:spcAft>
+              <a:defRPr sz="1050">
+                <a:solidFill>
+                  <a:srgbClr val="0F172A"/>
+                </a:solidFill>
+              </a:defRPr>
+            </a:pPr>
+            <a:r>
+              <a:t>• 1. Phân tích Giới tính (Gender):</a:t>
+            </a:r>
+          </a:p>
+          <a:p>
+            <a:pPr>
+              <a:spcAft>
+                <a:spcPts val="400"/>
+              </a:spcAft>
+              <a:defRPr sz="1050">
+                <a:solidFill>
+                  <a:srgbClr val="0F172A"/>
+                </a:solidFill>
+              </a:defRPr>
+            </a:pPr>
+            <a:r>
+              <a:t>• - Chi2 = 358.78, p-value = 1.87e-77, DoF = 3.</a:t>
+            </a:r>
+          </a:p>
+          <a:p>
+            <a:pPr>
+              <a:spcAft>
+                <a:spcPts val="400"/>
+              </a:spcAft>
+              <a:defRPr sz="1050">
+                <a:solidFill>
+                  <a:srgbClr val="0F172A"/>
+                </a:solidFill>
+              </a:defRPr>
+            </a:pPr>
+            <a:r>
+              <a:t>• - Cụm 0 (Action/Sci-Fi): 86.26% là Nam (áp đảo).</a:t>
+            </a:r>
+          </a:p>
+          <a:p>
+            <a:pPr>
+              <a:spcAft>
+                <a:spcPts val="400"/>
+              </a:spcAft>
+              <a:defRPr sz="1050">
+                <a:solidFill>
+                  <a:srgbClr val="0F172A"/>
+                </a:solidFill>
+              </a:defRPr>
+            </a:pPr>
+            <a:r>
+              <a:t>• - Cụm 3 (Thiếu nhi/Gia đình): 54.98% là Nữ.</a:t>
+            </a:r>
+          </a:p>
+          <a:p>
+            <a:pPr>
+              <a:spcAft>
+                <a:spcPts val="400"/>
+              </a:spcAft>
+              <a:defRPr sz="1050">
+                <a:solidFill>
+                  <a:srgbClr val="0F172A"/>
+                </a:solidFill>
+              </a:defRPr>
+            </a:pPr>
+            <a:r>
+              <a:t>• 2. Phân tích Nhóm tuổi (Age Groups):</a:t>
+            </a:r>
+          </a:p>
+          <a:p>
+            <a:pPr>
+              <a:spcAft>
+                <a:spcPts val="400"/>
+              </a:spcAft>
+              <a:defRPr sz="1050">
+                <a:solidFill>
+                  <a:srgbClr val="0F172A"/>
+                </a:solidFill>
+              </a:defRPr>
+            </a:pPr>
+            <a:r>
+              <a:t>• - Chi2 = 329.21, p-value = 4.58e-59, DoF = 18.</a:t>
+            </a:r>
+          </a:p>
+          <a:p>
+            <a:pPr>
+              <a:spcAft>
+                <a:spcPts val="400"/>
+              </a:spcAft>
+              <a:defRPr sz="1050">
+                <a:solidFill>
+                  <a:srgbClr val="0F172A"/>
+                </a:solidFill>
+              </a:defRPr>
+            </a:pPr>
+            <a:r>
+              <a:t>• - Nhóm Under 18: Tập trung cao đột biến tại Cụm 3 (14.43%, gấp 5 lần cụm khác).</a:t>
+            </a:r>
+          </a:p>
+          <a:p>
+            <a:pPr>
+              <a:spcAft>
+                <a:spcPts val="400"/>
+              </a:spcAft>
+              <a:defRPr sz="1050">
+                <a:solidFill>
+                  <a:srgbClr val="0F172A"/>
+                </a:solidFill>
+              </a:defRPr>
+            </a:pPr>
+            <a:r>
+              <a:t>• - Nhóm 45+ tuổi: Chiếm 31.33% tại Cụm 1 (Tâm lý/Drama).</a:t>
+            </a:r>
+          </a:p>
+          <a:p>
+            <a:pPr>
+              <a:spcAft>
+                <a:spcPts val="400"/>
+              </a:spcAft>
+              <a:defRPr sz="1050">
+                <a:solidFill>
+                  <a:srgbClr val="0F172A"/>
+                </a:solidFill>
+              </a:defRPr>
+            </a:pPr>
+            <a:r>
+              <a:t>• =&gt; Kết luận Q1: Giới tính &amp; độ tuổi tác động cực kỳ mạnh mẽ đến gu điện ảnh.</a:t>
+            </a:r>
+          </a:p>
+        </p:txBody>
+      </p:sp>
+      <p:pic>
+        <p:nvPicPr>
+          <p:cNvPr id="5" name="Picture 4" descr="cluster_gender_distribution.png"/>
+          <p:cNvPicPr>
+            <a:picLocks noChangeAspect="1"/>
+          </p:cNvPicPr>
+          <p:nvPr/>
+        </p:nvPicPr>
+        <p:blipFill>
+          <a:blip r:embed="rId2"/>
+          <a:stretch>
+            <a:fillRect/>
+          </a:stretch>
+        </p:blipFill>
+        <p:spPr>
+          <a:xfrm>
+            <a:off x="5943600" y="1645920"/>
+            <a:ext cx="5486400" cy="3048000"/>
+          </a:xfrm>
+          <a:prstGeom prst="rect">
+            <a:avLst/>
+          </a:prstGeom>
+        </p:spPr>
+      </p:pic>
+    </p:spTree>
+  </p:cSld>
+  <p:clrMapOvr>
+    <a:masterClrMapping/>
+  </p:clrMapOvr>
+</p:sld>
+</file>
+
+<file path=ppt/slides/slide12.xml><?xml version="1.0" encoding="utf-8"?>
+<p:sld xmlns:a="http://schemas.openxmlformats.org/drawingml/2006/main" xmlns:p="http://schemas.openxmlformats.org/presentationml/2006/main" xmlns:r="http://schemas.openxmlformats.org/officeDocument/2006/relationships">
+  <p:cSld>
+    <p:spTree>
+      <p:nvGrpSpPr>
+        <p:cNvPr id="1" name=""/>
+        <p:cNvGrpSpPr/>
+        <p:nvPr/>
+      </p:nvGrpSpPr>
+      <p:grpSpPr/>
+      <p:sp>
+        <p:nvSpPr>
+          <p:cNvPr id="2" name="TextBox 1"/>
+          <p:cNvSpPr txBox="1"/>
+          <p:nvPr/>
+        </p:nvSpPr>
+        <p:spPr>
+          <a:xfrm>
+            <a:off x="731520" y="365760"/>
+            <a:ext cx="10058400" cy="274320"/>
+          </a:xfrm>
+          <a:prstGeom prst="rect">
+            <a:avLst/>
+          </a:prstGeom>
+          <a:noFill/>
+        </p:spPr>
+        <p:txBody>
+          <a:bodyPr wrap="square">
+            <a:spAutoFit/>
+          </a:bodyPr>
+          <a:lstStyle/>
+          <a:p>
+            <a:pPr>
+              <a:defRPr sz="900" b="1">
+                <a:solidFill>
+                  <a:srgbClr val="2563EB"/>
+                </a:solidFill>
+              </a:defRPr>
+            </a:pPr>
+            <a:r>
+              <a:t>KHO DỮ LIỆU &amp; KHAI PHÁ DỮ LIỆU • PTIT</a:t>
+            </a:r>
+          </a:p>
+        </p:txBody>
+      </p:sp>
+      <p:sp>
+        <p:nvSpPr>
+          <p:cNvPr id="3" name="TextBox 2"/>
+          <p:cNvSpPr txBox="1"/>
+          <p:nvPr/>
+        </p:nvSpPr>
+        <p:spPr>
+          <a:xfrm>
+            <a:off x="731520" y="594360"/>
+            <a:ext cx="10515600" cy="731520"/>
+          </a:xfrm>
+          <a:prstGeom prst="rect">
+            <a:avLst/>
+          </a:prstGeom>
+          <a:noFill/>
+        </p:spPr>
+        <p:txBody>
+          <a:bodyPr wrap="square">
+            <a:spAutoFit/>
+          </a:bodyPr>
+          <a:lstStyle/>
+          <a:p>
+            <a:pPr>
+              <a:defRPr sz="2200" b="1">
+                <a:solidFill>
+                  <a:srgbClr val="1E3A8A"/>
+                </a:solidFill>
+              </a:defRPr>
+            </a:pPr>
+            <a:r>
               <a:t>Hệ Gợi Ý Phim: Lọc Cộng Tác (Collaborative Filtering - Q2)</a:t>
             </a:r>
           </a:p>
@@ -4959,7 +5649,7 @@
 </p:sld>
 </file>
 
-<file path=ppt/slides/slide11.xml><?xml version="1.0" encoding="utf-8"?>
+<file path=ppt/slides/slide13.xml><?xml version="1.0" encoding="utf-8"?>
 <p:sld xmlns:a="http://schemas.openxmlformats.org/drawingml/2006/main" xmlns:p="http://schemas.openxmlformats.org/presentationml/2006/main" xmlns:r="http://schemas.openxmlformats.org/officeDocument/2006/relationships">
   <p:cSld>
     <p:spTree>
@@ -5314,7 +6004,7 @@
 </p:sld>
 </file>
 
-<file path=ppt/slides/slide12.xml><?xml version="1.0" encoding="utf-8"?>
+<file path=ppt/slides/slide14.xml><?xml version="1.0" encoding="utf-8"?>
 <p:sld xmlns:a="http://schemas.openxmlformats.org/drawingml/2006/main" xmlns:p="http://schemas.openxmlformats.org/presentationml/2006/main" xmlns:r="http://schemas.openxmlformats.org/officeDocument/2006/relationships">
   <p:cSld>
     <p:spTree>
@@ -5548,7 +6238,7 @@
               </a:defRPr>
             </a:pPr>
             <a:r>
-              <a:t>👥 Trang 2: Thị Hiếu &amp; Cụm Khán Giả (Q1)</a:t>
+              <a:t>👥 Trang 2: Thị Hiếu &amp; Cụm Khán GiẢ (Q1)</a:t>
             </a:r>
           </a:p>
           <a:p>
@@ -5810,7 +6500,7 @@
 </p:sld>
 </file>
 
-<file path=ppt/slides/slide13.xml><?xml version="1.0" encoding="utf-8"?>
+<file path=ppt/slides/slide15.xml><?xml version="1.0" encoding="utf-8"?>
 <p:sld xmlns:a="http://schemas.openxmlformats.org/drawingml/2006/main" xmlns:p="http://schemas.openxmlformats.org/presentationml/2006/main" xmlns:r="http://schemas.openxmlformats.org/officeDocument/2006/relationships">
   <p:cSld>
     <p:spTree>
@@ -6309,7 +6999,7 @@
 </p:sld>
 </file>
 
-<file path=ppt/slides/slide14.xml><?xml version="1.0" encoding="utf-8"?>
+<file path=ppt/slides/slide16.xml><?xml version="1.0" encoding="utf-8"?>
 <p:sld xmlns:a="http://schemas.openxmlformats.org/drawingml/2006/main" xmlns:p="http://schemas.openxmlformats.org/presentationml/2006/main" xmlns:r="http://schemas.openxmlformats.org/officeDocument/2006/relationships">
   <p:cSld>
     <p:spTree>
@@ -6482,6 +7172,538 @@
 </file>
 
 <file path=ppt/slides/slide2.xml><?xml version="1.0" encoding="utf-8"?>
+<p:sld xmlns:a="http://schemas.openxmlformats.org/drawingml/2006/main" xmlns:p="http://schemas.openxmlformats.org/presentationml/2006/main" xmlns:r="http://schemas.openxmlformats.org/officeDocument/2006/relationships">
+  <p:cSld>
+    <p:spTree>
+      <p:nvGrpSpPr>
+        <p:cNvPr id="1" name=""/>
+        <p:cNvGrpSpPr/>
+        <p:nvPr/>
+      </p:nvGrpSpPr>
+      <p:grpSpPr/>
+      <p:sp>
+        <p:nvSpPr>
+          <p:cNvPr id="2" name="TextBox 1"/>
+          <p:cNvSpPr txBox="1"/>
+          <p:nvPr/>
+        </p:nvSpPr>
+        <p:spPr>
+          <a:xfrm>
+            <a:off x="731520" y="365760"/>
+            <a:ext cx="10058400" cy="274320"/>
+          </a:xfrm>
+          <a:prstGeom prst="rect">
+            <a:avLst/>
+          </a:prstGeom>
+          <a:noFill/>
+        </p:spPr>
+        <p:txBody>
+          <a:bodyPr wrap="square">
+            <a:spAutoFit/>
+          </a:bodyPr>
+          <a:lstStyle/>
+          <a:p>
+            <a:pPr>
+              <a:defRPr sz="900" b="1">
+                <a:solidFill>
+                  <a:srgbClr val="2563EB"/>
+                </a:solidFill>
+              </a:defRPr>
+            </a:pPr>
+            <a:r>
+              <a:t>KHO DỮ LIỆU &amp; KHAI PHÁ DỮ LIỆU • PTIT</a:t>
+            </a:r>
+          </a:p>
+        </p:txBody>
+      </p:sp>
+      <p:sp>
+        <p:nvSpPr>
+          <p:cNvPr id="3" name="TextBox 2"/>
+          <p:cNvSpPr txBox="1"/>
+          <p:nvPr/>
+        </p:nvSpPr>
+        <p:spPr>
+          <a:xfrm>
+            <a:off x="731520" y="594360"/>
+            <a:ext cx="10515600" cy="731520"/>
+          </a:xfrm>
+          <a:prstGeom prst="rect">
+            <a:avLst/>
+          </a:prstGeom>
+          <a:noFill/>
+        </p:spPr>
+        <p:txBody>
+          <a:bodyPr wrap="square">
+            <a:spAutoFit/>
+          </a:bodyPr>
+          <a:lstStyle/>
+          <a:p>
+            <a:pPr>
+              <a:defRPr sz="2200" b="1">
+                <a:solidFill>
+                  <a:srgbClr val="1E3A8A"/>
+                </a:solidFill>
+              </a:defRPr>
+            </a:pPr>
+            <a:r>
+              <a:t>Phân Công Nhiệm Vụ Nhóm Sinh Viên (Mô Hình 2 Người - 50% / 50%)</a:t>
+            </a:r>
+          </a:p>
+        </p:txBody>
+      </p:sp>
+      <p:sp>
+        <p:nvSpPr>
+          <p:cNvPr id="4" name="Rounded Rectangle 3"/>
+          <p:cNvSpPr/>
+          <p:nvPr/>
+        </p:nvSpPr>
+        <p:spPr>
+          <a:xfrm>
+            <a:off x="731520" y="1645920"/>
+            <a:ext cx="5120640" cy="4389120"/>
+          </a:xfrm>
+          <a:prstGeom prst="roundRect">
+            <a:avLst/>
+          </a:prstGeom>
+          <a:solidFill>
+            <a:srgbClr val="F8FAFC"/>
+          </a:solidFill>
+          <a:ln w="12700">
+            <a:solidFill>
+              <a:srgbClr val="E2E8F0"/>
+            </a:solidFill>
+          </a:ln>
+        </p:spPr>
+        <p:style>
+          <a:lnRef idx="1">
+            <a:schemeClr val="accent1"/>
+          </a:lnRef>
+          <a:fillRef idx="3">
+            <a:schemeClr val="accent1"/>
+          </a:fillRef>
+          <a:effectRef idx="2">
+            <a:schemeClr val="accent1"/>
+          </a:effectRef>
+          <a:fontRef idx="minor">
+            <a:schemeClr val="lt1"/>
+          </a:fontRef>
+        </p:style>
+        <p:txBody>
+          <a:bodyPr rtlCol="0" anchor="ctr" wrap="square" lIns="182880" rIns="182880" tIns="182880" bIns="182880"/>
+          <a:lstStyle/>
+          <a:p>
+            <a:pPr algn="ctr">
+              <a:spcAft>
+                <a:spcPts val="600"/>
+              </a:spcAft>
+              <a:defRPr sz="1300" b="1">
+                <a:solidFill>
+                  <a:srgbClr val="1E3A8A"/>
+                </a:solidFill>
+              </a:defRPr>
+            </a:pPr>
+            <a:r>
+              <a:t>👤 Thành viên 1: Data Engineer &amp; DW Architect (50%)</a:t>
+            </a:r>
+          </a:p>
+          <a:p>
+            <a:pPr>
+              <a:spcAft>
+                <a:spcPts val="400"/>
+              </a:spcAft>
+              <a:defRPr sz="1050">
+                <a:solidFill>
+                  <a:srgbClr val="0F172A"/>
+                </a:solidFill>
+              </a:defRPr>
+            </a:pPr>
+            <a:r>
+              <a:t>• 1. Thu thập &amp; Tiền xử lý dữ liệu:</a:t>
+            </a:r>
+          </a:p>
+          <a:p>
+            <a:pPr>
+              <a:spcAft>
+                <a:spcPts val="400"/>
+              </a:spcAft>
+              <a:defRPr sz="1050">
+                <a:solidFill>
+                  <a:srgbClr val="0F172A"/>
+                </a:solidFill>
+              </a:defRPr>
+            </a:pPr>
+            <a:r>
+              <a:t>•    - Tải MovieLens 1M, streaming lọc IMDb, xử lý Netflix.</a:t>
+            </a:r>
+          </a:p>
+          <a:p>
+            <a:pPr>
+              <a:spcAft>
+                <a:spcPts val="400"/>
+              </a:spcAft>
+              <a:defRPr sz="1050">
+                <a:solidFill>
+                  <a:srgbClr val="0F172A"/>
+                </a:solidFill>
+              </a:defRPr>
+            </a:pPr>
+            <a:r>
+              <a:t>•    - Làm sạch, chuẩn hóa và xử lý missing data.</a:t>
+            </a:r>
+          </a:p>
+          <a:p>
+            <a:pPr>
+              <a:spcAft>
+                <a:spcPts val="400"/>
+              </a:spcAft>
+              <a:defRPr sz="1050">
+                <a:solidFill>
+                  <a:srgbClr val="0F172A"/>
+                </a:solidFill>
+              </a:defRPr>
+            </a:pPr>
+            <a:r>
+              <a:t>• 2. Thiết kế &amp; Hiện thực hóa Kho dữ liệu:</a:t>
+            </a:r>
+          </a:p>
+          <a:p>
+            <a:pPr>
+              <a:spcAft>
+                <a:spcPts val="400"/>
+              </a:spcAft>
+              <a:defRPr sz="1050">
+                <a:solidFill>
+                  <a:srgbClr val="0F172A"/>
+                </a:solidFill>
+              </a:defRPr>
+            </a:pPr>
+            <a:r>
+              <a:t>•    - Thiết kế Star Schema, khóa thay thế, Bridge table.</a:t>
+            </a:r>
+          </a:p>
+          <a:p>
+            <a:pPr>
+              <a:spcAft>
+                <a:spcPts val="400"/>
+              </a:spcAft>
+              <a:defRPr sz="1050">
+                <a:solidFill>
+                  <a:srgbClr val="0F172A"/>
+                </a:solidFill>
+              </a:defRPr>
+            </a:pPr>
+            <a:r>
+              <a:t>•    - Viết DDL và pipeline nạp SQL Server (stg &amp; dw).</a:t>
+            </a:r>
+          </a:p>
+          <a:p>
+            <a:pPr>
+              <a:spcAft>
+                <a:spcPts val="400"/>
+              </a:spcAft>
+              <a:defRPr sz="1050">
+                <a:solidFill>
+                  <a:srgbClr val="0F172A"/>
+                </a:solidFill>
+              </a:defRPr>
+            </a:pPr>
+            <a:r>
+              <a:t>•    - Kiểm toán chất lượng dữ liệu (Data Quality Audit 5/5 tiêu chí).</a:t>
+            </a:r>
+          </a:p>
+          <a:p>
+            <a:pPr>
+              <a:spcAft>
+                <a:spcPts val="400"/>
+              </a:spcAft>
+              <a:defRPr sz="1050">
+                <a:solidFill>
+                  <a:srgbClr val="0F172A"/>
+                </a:solidFill>
+              </a:defRPr>
+            </a:pPr>
+            <a:r>
+              <a:t>• 3. Phân tích OLAP đa chiều (Trả lời Q3):</a:t>
+            </a:r>
+          </a:p>
+          <a:p>
+            <a:pPr>
+              <a:spcAft>
+                <a:spcPts val="400"/>
+              </a:spcAft>
+              <a:defRPr sz="1050">
+                <a:solidFill>
+                  <a:srgbClr val="0F172A"/>
+                </a:solidFill>
+              </a:defRPr>
+            </a:pPr>
+            <a:r>
+              <a:t>•    - Viết truy vấn CUBE, ROLLUP, window function LAG() tính QoQ.</a:t>
+            </a:r>
+          </a:p>
+          <a:p>
+            <a:pPr>
+              <a:spcAft>
+                <a:spcPts val="400"/>
+              </a:spcAft>
+              <a:defRPr sz="1050">
+                <a:solidFill>
+                  <a:srgbClr val="0F172A"/>
+                </a:solidFill>
+              </a:defRPr>
+            </a:pPr>
+            <a:r>
+              <a:t>• 4. Tự động hóa &amp; Tài liệu:</a:t>
+            </a:r>
+          </a:p>
+          <a:p>
+            <a:pPr>
+              <a:spcAft>
+                <a:spcPts val="400"/>
+              </a:spcAft>
+              <a:defRPr sz="1050">
+                <a:solidFill>
+                  <a:srgbClr val="0F172A"/>
+                </a:solidFill>
+              </a:defRPr>
+            </a:pPr>
+            <a:r>
+              <a:t>•    - Viết master script run_all.sh, Docker, viết Chương 1-3 báo cáo.</a:t>
+            </a:r>
+          </a:p>
+        </p:txBody>
+      </p:sp>
+      <p:sp>
+        <p:nvSpPr>
+          <p:cNvPr id="5" name="Rounded Rectangle 4"/>
+          <p:cNvSpPr/>
+          <p:nvPr/>
+        </p:nvSpPr>
+        <p:spPr>
+          <a:xfrm>
+            <a:off x="6217920" y="1645920"/>
+            <a:ext cx="5120640" cy="4389120"/>
+          </a:xfrm>
+          <a:prstGeom prst="roundRect">
+            <a:avLst/>
+          </a:prstGeom>
+          <a:solidFill>
+            <a:srgbClr val="F8FAFC"/>
+          </a:solidFill>
+          <a:ln w="12700">
+            <a:solidFill>
+              <a:srgbClr val="E2E8F0"/>
+            </a:solidFill>
+          </a:ln>
+        </p:spPr>
+        <p:style>
+          <a:lnRef idx="1">
+            <a:schemeClr val="accent1"/>
+          </a:lnRef>
+          <a:fillRef idx="3">
+            <a:schemeClr val="accent1"/>
+          </a:fillRef>
+          <a:effectRef idx="2">
+            <a:schemeClr val="accent1"/>
+          </a:effectRef>
+          <a:fontRef idx="minor">
+            <a:schemeClr val="lt1"/>
+          </a:fontRef>
+        </p:style>
+        <p:txBody>
+          <a:bodyPr rtlCol="0" anchor="ctr" wrap="square" lIns="182880" rIns="182880" tIns="182880" bIns="182880"/>
+          <a:lstStyle/>
+          <a:p>
+            <a:pPr algn="ctr">
+              <a:spcAft>
+                <a:spcPts val="600"/>
+              </a:spcAft>
+              <a:defRPr sz="1300" b="1">
+                <a:solidFill>
+                  <a:srgbClr val="1E3A8A"/>
+                </a:solidFill>
+              </a:defRPr>
+            </a:pPr>
+            <a:r>
+              <a:t>👤 Thành viên 2: Data Scientist &amp; BI Developer (50%)</a:t>
+            </a:r>
+          </a:p>
+          <a:p>
+            <a:pPr>
+              <a:spcAft>
+                <a:spcPts val="400"/>
+              </a:spcAft>
+              <a:defRPr sz="1050">
+                <a:solidFill>
+                  <a:srgbClr val="0F172A"/>
+                </a:solidFill>
+              </a:defRPr>
+            </a:pPr>
+            <a:r>
+              <a:t>• 1. Khai phá dữ liệu &amp; Phân cụm (Trả lời Q1):</a:t>
+            </a:r>
+          </a:p>
+          <a:p>
+            <a:pPr>
+              <a:spcAft>
+                <a:spcPts val="400"/>
+              </a:spcAft>
+              <a:defRPr sz="1050">
+                <a:solidFill>
+                  <a:srgbClr val="0F172A"/>
+                </a:solidFill>
+              </a:defRPr>
+            </a:pPr>
+            <a:r>
+              <a:t>•    - Trích xuất vector đặc trưng sở thích người dùng 36 chiều.</a:t>
+            </a:r>
+          </a:p>
+          <a:p>
+            <a:pPr>
+              <a:spcAft>
+                <a:spcPts val="400"/>
+              </a:spcAft>
+              <a:defRPr sz="1050">
+                <a:solidFill>
+                  <a:srgbClr val="0F172A"/>
+                </a:solidFill>
+              </a:defRPr>
+            </a:pPr>
+            <a:r>
+              <a:t>•    - Huấn luyện K-Means (K=4), đánh giá Elbow, Silhouette.</a:t>
+            </a:r>
+          </a:p>
+          <a:p>
+            <a:pPr>
+              <a:spcAft>
+                <a:spcPts val="400"/>
+              </a:spcAft>
+              <a:defRPr sz="1050">
+                <a:solidFill>
+                  <a:srgbClr val="0F172A"/>
+                </a:solidFill>
+              </a:defRPr>
+            </a:pPr>
+            <a:r>
+              <a:t>•    - Thực hiện kiểm định thống kê Chi-Square (p &lt; 0.001) &amp; PCA 2D.</a:t>
+            </a:r>
+          </a:p>
+          <a:p>
+            <a:pPr>
+              <a:spcAft>
+                <a:spcPts val="400"/>
+              </a:spcAft>
+              <a:defRPr sz="1050">
+                <a:solidFill>
+                  <a:srgbClr val="0F172A"/>
+                </a:solidFill>
+              </a:defRPr>
+            </a:pPr>
+            <a:r>
+              <a:t>• 2. Xây dựng Hệ gợi ý &amp; Luật kết hợp (Trả lời Q2):</a:t>
+            </a:r>
+          </a:p>
+          <a:p>
+            <a:pPr>
+              <a:spcAft>
+                <a:spcPts val="400"/>
+              </a:spcAft>
+              <a:defRPr sz="1050">
+                <a:solidFill>
+                  <a:srgbClr val="0F172A"/>
+                </a:solidFill>
+              </a:defRPr>
+            </a:pPr>
+            <a:r>
+              <a:t>•    - Triển khai Item-based Collaborative Filtering (RMSE 1.01).</a:t>
+            </a:r>
+          </a:p>
+          <a:p>
+            <a:pPr>
+              <a:spcAft>
+                <a:spcPts val="400"/>
+              </a:spcAft>
+              <a:defRPr sz="1050">
+                <a:solidFill>
+                  <a:srgbClr val="0F172A"/>
+                </a:solidFill>
+              </a:defRPr>
+            </a:pPr>
+            <a:r>
+              <a:t>•    - Áp dụng thuật toán FP-Growth khai phá luật đạo diễn (Lift &gt; 1.5).</a:t>
+            </a:r>
+          </a:p>
+          <a:p>
+            <a:pPr>
+              <a:spcAft>
+                <a:spcPts val="400"/>
+              </a:spcAft>
+              <a:defRPr sz="1050">
+                <a:solidFill>
+                  <a:srgbClr val="0F172A"/>
+                </a:solidFill>
+              </a:defRPr>
+            </a:pPr>
+            <a:r>
+              <a:t>• 3. Trực quan hóa &amp; Ứng dụng tương tác:</a:t>
+            </a:r>
+          </a:p>
+          <a:p>
+            <a:pPr>
+              <a:spcAft>
+                <a:spcPts val="400"/>
+              </a:spcAft>
+              <a:defRPr sz="1050">
+                <a:solidFill>
+                  <a:srgbClr val="0F172A"/>
+                </a:solidFill>
+              </a:defRPr>
+            </a:pPr>
+            <a:r>
+              <a:t>•    - Lập trình giao diện Web App Demo (Streamlit 4 trang).</a:t>
+            </a:r>
+          </a:p>
+          <a:p>
+            <a:pPr>
+              <a:spcAft>
+                <a:spcPts val="400"/>
+              </a:spcAft>
+              <a:defRPr sz="1050">
+                <a:solidFill>
+                  <a:srgbClr val="0F172A"/>
+                </a:solidFill>
+              </a:defRPr>
+            </a:pPr>
+            <a:r>
+              <a:t>•    - Thiết kế Dashboard Power BI &amp; Slide thuyết trình PowerPoint.</a:t>
+            </a:r>
+          </a:p>
+          <a:p>
+            <a:pPr>
+              <a:spcAft>
+                <a:spcPts val="400"/>
+              </a:spcAft>
+              <a:defRPr sz="1050">
+                <a:solidFill>
+                  <a:srgbClr val="0F172A"/>
+                </a:solidFill>
+              </a:defRPr>
+            </a:pPr>
+            <a:r>
+              <a:t>•    - Viết Chương 4-6 báo cáo học thuật.</a:t>
+            </a:r>
+          </a:p>
+        </p:txBody>
+      </p:sp>
+    </p:spTree>
+  </p:cSld>
+  <p:clrMapOvr>
+    <a:masterClrMapping/>
+  </p:clrMapOvr>
+</p:sld>
+</file>
+
+<file path=ppt/slides/slide3.xml><?xml version="1.0" encoding="utf-8"?>
 <p:sld xmlns:a="http://schemas.openxmlformats.org/drawingml/2006/main" xmlns:p="http://schemas.openxmlformats.org/presentationml/2006/main" xmlns:r="http://schemas.openxmlformats.org/officeDocument/2006/relationships">
   <p:cSld>
     <p:spTree>
@@ -6920,7 +8142,645 @@
 </p:sld>
 </file>
 
-<file path=ppt/slides/slide3.xml><?xml version="1.0" encoding="utf-8"?>
+<file path=ppt/slides/slide4.xml><?xml version="1.0" encoding="utf-8"?>
+<p:sld xmlns:a="http://schemas.openxmlformats.org/drawingml/2006/main" xmlns:p="http://schemas.openxmlformats.org/presentationml/2006/main" xmlns:r="http://schemas.openxmlformats.org/officeDocument/2006/relationships">
+  <p:cSld>
+    <p:spTree>
+      <p:nvGrpSpPr>
+        <p:cNvPr id="1" name=""/>
+        <p:cNvGrpSpPr/>
+        <p:nvPr/>
+      </p:nvGrpSpPr>
+      <p:grpSpPr/>
+      <p:sp>
+        <p:nvSpPr>
+          <p:cNvPr id="2" name="TextBox 1"/>
+          <p:cNvSpPr txBox="1"/>
+          <p:nvPr/>
+        </p:nvSpPr>
+        <p:spPr>
+          <a:xfrm>
+            <a:off x="731520" y="365760"/>
+            <a:ext cx="10058400" cy="274320"/>
+          </a:xfrm>
+          <a:prstGeom prst="rect">
+            <a:avLst/>
+          </a:prstGeom>
+          <a:noFill/>
+        </p:spPr>
+        <p:txBody>
+          <a:bodyPr wrap="square">
+            <a:spAutoFit/>
+          </a:bodyPr>
+          <a:lstStyle/>
+          <a:p>
+            <a:pPr>
+              <a:defRPr sz="900" b="1">
+                <a:solidFill>
+                  <a:srgbClr val="2563EB"/>
+                </a:solidFill>
+              </a:defRPr>
+            </a:pPr>
+            <a:r>
+              <a:t>KHO DỮ LIỆU &amp; KHAI PHÁ DỮ LIỆU • PTIT</a:t>
+            </a:r>
+          </a:p>
+        </p:txBody>
+      </p:sp>
+      <p:sp>
+        <p:nvSpPr>
+          <p:cNvPr id="3" name="TextBox 2"/>
+          <p:cNvSpPr txBox="1"/>
+          <p:nvPr/>
+        </p:nvSpPr>
+        <p:spPr>
+          <a:xfrm>
+            <a:off x="731520" y="594360"/>
+            <a:ext cx="10515600" cy="731520"/>
+          </a:xfrm>
+          <a:prstGeom prst="rect">
+            <a:avLst/>
+          </a:prstGeom>
+          <a:noFill/>
+        </p:spPr>
+        <p:txBody>
+          <a:bodyPr wrap="square">
+            <a:spAutoFit/>
+          </a:bodyPr>
+          <a:lstStyle/>
+          <a:p>
+            <a:pPr>
+              <a:defRPr sz="2200" b="1">
+                <a:solidFill>
+                  <a:srgbClr val="1E3A8A"/>
+                </a:solidFill>
+              </a:defRPr>
+            </a:pPr>
+            <a:r>
+              <a:t>Sơ Đồ Kiến Trúc Tổng Thể Hệ Thống (Mô Hình 4 Tầng OLAM)</a:t>
+            </a:r>
+          </a:p>
+        </p:txBody>
+      </p:sp>
+      <p:pic>
+        <p:nvPicPr>
+          <p:cNvPr id="4" name="Picture 3" descr="system_architecture.png"/>
+          <p:cNvPicPr>
+            <a:picLocks noChangeAspect="1"/>
+          </p:cNvPicPr>
+          <p:nvPr/>
+        </p:nvPicPr>
+        <p:blipFill>
+          <a:blip r:embed="rId2"/>
+          <a:stretch>
+            <a:fillRect/>
+          </a:stretch>
+        </p:blipFill>
+        <p:spPr>
+          <a:xfrm>
+            <a:off x="731520" y="1463040"/>
+            <a:ext cx="7863840" cy="4754880"/>
+          </a:xfrm>
+          <a:prstGeom prst="rect">
+            <a:avLst/>
+          </a:prstGeom>
+        </p:spPr>
+      </p:pic>
+      <p:sp>
+        <p:nvSpPr>
+          <p:cNvPr id="5" name="Rounded Rectangle 4"/>
+          <p:cNvSpPr/>
+          <p:nvPr/>
+        </p:nvSpPr>
+        <p:spPr>
+          <a:xfrm>
+            <a:off x="8778240" y="1463040"/>
+            <a:ext cx="2743200" cy="4754880"/>
+          </a:xfrm>
+          <a:prstGeom prst="roundRect">
+            <a:avLst/>
+          </a:prstGeom>
+          <a:solidFill>
+            <a:srgbClr val="F8FAFC"/>
+          </a:solidFill>
+          <a:ln w="12700">
+            <a:solidFill>
+              <a:srgbClr val="E2E8F0"/>
+            </a:solidFill>
+          </a:ln>
+        </p:spPr>
+        <p:style>
+          <a:lnRef idx="1">
+            <a:schemeClr val="accent1"/>
+          </a:lnRef>
+          <a:fillRef idx="3">
+            <a:schemeClr val="accent1"/>
+          </a:fillRef>
+          <a:effectRef idx="2">
+            <a:schemeClr val="accent1"/>
+          </a:effectRef>
+          <a:fontRef idx="minor">
+            <a:schemeClr val="lt1"/>
+          </a:fontRef>
+        </p:style>
+        <p:txBody>
+          <a:bodyPr rtlCol="0" anchor="ctr" wrap="square" lIns="182880" rIns="182880" tIns="182880" bIns="182880"/>
+          <a:lstStyle/>
+          <a:p>
+            <a:pPr algn="ctr">
+              <a:spcAft>
+                <a:spcPts val="600"/>
+              </a:spcAft>
+              <a:defRPr sz="1300" b="1">
+                <a:solidFill>
+                  <a:srgbClr val="1E3A8A"/>
+                </a:solidFill>
+              </a:defRPr>
+            </a:pPr>
+            <a:r>
+              <a:t>🏛️ 4 Tầng Kiến Trúc</a:t>
+            </a:r>
+          </a:p>
+          <a:p>
+            <a:pPr>
+              <a:spcAft>
+                <a:spcPts val="400"/>
+              </a:spcAft>
+              <a:defRPr sz="1050">
+                <a:solidFill>
+                  <a:srgbClr val="0F172A"/>
+                </a:solidFill>
+              </a:defRPr>
+            </a:pPr>
+            <a:r>
+              <a:t>• Tầng 1: Nguồn Dữ Liệu &amp; ETL</a:t>
+            </a:r>
+          </a:p>
+          <a:p>
+            <a:pPr>
+              <a:spcAft>
+                <a:spcPts val="400"/>
+              </a:spcAft>
+              <a:defRPr sz="1050">
+                <a:solidFill>
+                  <a:srgbClr val="0F172A"/>
+                </a:solidFill>
+              </a:defRPr>
+            </a:pPr>
+            <a:r>
+              <a:t>• Tích hợp MovieLens 1M, IMDb streaming và Netflix catalog.</a:t>
+            </a:r>
+          </a:p>
+          <a:p>
+            <a:pPr>
+              <a:spcAft>
+                <a:spcPts val="400"/>
+              </a:spcAft>
+              <a:defRPr sz="1050">
+                <a:solidFill>
+                  <a:srgbClr val="0F172A"/>
+                </a:solidFill>
+              </a:defRPr>
+            </a:pPr>
+            <a:r>
+              <a:t>• Tầng 2: Kho Dữ Liệu Đa Chiều</a:t>
+            </a:r>
+          </a:p>
+          <a:p>
+            <a:pPr>
+              <a:spcAft>
+                <a:spcPts val="400"/>
+              </a:spcAft>
+              <a:defRPr sz="1050">
+                <a:solidFill>
+                  <a:srgbClr val="0F172A"/>
+                </a:solidFill>
+              </a:defRPr>
+            </a:pPr>
+            <a:r>
+              <a:t>• SQL Server 2022, mô hình Star Schema 6 bảng (1M ratings).</a:t>
+            </a:r>
+          </a:p>
+          <a:p>
+            <a:pPr>
+              <a:spcAft>
+                <a:spcPts val="400"/>
+              </a:spcAft>
+              <a:defRPr sz="1050">
+                <a:solidFill>
+                  <a:srgbClr val="0F172A"/>
+                </a:solidFill>
+              </a:defRPr>
+            </a:pPr>
+            <a:r>
+              <a:t>• Tầng 3: Động Cơ OLAP &amp; Khai Phá</a:t>
+            </a:r>
+          </a:p>
+          <a:p>
+            <a:pPr>
+              <a:spcAft>
+                <a:spcPts val="400"/>
+              </a:spcAft>
+              <a:defRPr sz="1050">
+                <a:solidFill>
+                  <a:srgbClr val="0F172A"/>
+                </a:solidFill>
+              </a:defRPr>
+            </a:pPr>
+            <a:r>
+              <a:t>• K-Means (K=4), Item-CF (RMSE 1.01), FP-Growth đạo diễn, CUBE/ROLLUP.</a:t>
+            </a:r>
+          </a:p>
+          <a:p>
+            <a:pPr>
+              <a:spcAft>
+                <a:spcPts val="400"/>
+              </a:spcAft>
+              <a:defRPr sz="1050">
+                <a:solidFill>
+                  <a:srgbClr val="0F172A"/>
+                </a:solidFill>
+              </a:defRPr>
+            </a:pPr>
+            <a:r>
+              <a:t>• Tầng 4: Tầng Biểu Diễn GUI</a:t>
+            </a:r>
+          </a:p>
+          <a:p>
+            <a:pPr>
+              <a:spcAft>
+                <a:spcPts val="400"/>
+              </a:spcAft>
+              <a:defRPr sz="1050">
+                <a:solidFill>
+                  <a:srgbClr val="0F172A"/>
+                </a:solidFill>
+              </a:defRPr>
+            </a:pPr>
+            <a:r>
+              <a:t>• Streamlit Web App 4 tabs, Power BI Dashboard 3 trang.</a:t>
+            </a:r>
+          </a:p>
+        </p:txBody>
+      </p:sp>
+    </p:spTree>
+  </p:cSld>
+  <p:clrMapOvr>
+    <a:masterClrMapping/>
+  </p:clrMapOvr>
+</p:sld>
+</file>
+
+<file path=ppt/slides/slide5.xml><?xml version="1.0" encoding="utf-8"?>
+<p:sld xmlns:a="http://schemas.openxmlformats.org/drawingml/2006/main" xmlns:p="http://schemas.openxmlformats.org/presentationml/2006/main" xmlns:r="http://schemas.openxmlformats.org/officeDocument/2006/relationships">
+  <p:cSld>
+    <p:spTree>
+      <p:nvGrpSpPr>
+        <p:cNvPr id="1" name=""/>
+        <p:cNvGrpSpPr/>
+        <p:nvPr/>
+      </p:nvGrpSpPr>
+      <p:grpSpPr/>
+      <p:sp>
+        <p:nvSpPr>
+          <p:cNvPr id="2" name="TextBox 1"/>
+          <p:cNvSpPr txBox="1"/>
+          <p:nvPr/>
+        </p:nvSpPr>
+        <p:spPr>
+          <a:xfrm>
+            <a:off x="731520" y="365760"/>
+            <a:ext cx="10058400" cy="274320"/>
+          </a:xfrm>
+          <a:prstGeom prst="rect">
+            <a:avLst/>
+          </a:prstGeom>
+          <a:noFill/>
+        </p:spPr>
+        <p:txBody>
+          <a:bodyPr wrap="square">
+            <a:spAutoFit/>
+          </a:bodyPr>
+          <a:lstStyle/>
+          <a:p>
+            <a:pPr>
+              <a:defRPr sz="900" b="1">
+                <a:solidFill>
+                  <a:srgbClr val="2563EB"/>
+                </a:solidFill>
+              </a:defRPr>
+            </a:pPr>
+            <a:r>
+              <a:t>KHO DỮ LIỆU &amp; KHAI PHÁ DỮ LIỆU • PTIT</a:t>
+            </a:r>
+          </a:p>
+        </p:txBody>
+      </p:sp>
+      <p:sp>
+        <p:nvSpPr>
+          <p:cNvPr id="3" name="TextBox 2"/>
+          <p:cNvSpPr txBox="1"/>
+          <p:nvPr/>
+        </p:nvSpPr>
+        <p:spPr>
+          <a:xfrm>
+            <a:off x="731520" y="594360"/>
+            <a:ext cx="10515600" cy="731520"/>
+          </a:xfrm>
+          <a:prstGeom prst="rect">
+            <a:avLst/>
+          </a:prstGeom>
+          <a:noFill/>
+        </p:spPr>
+        <p:txBody>
+          <a:bodyPr wrap="square">
+            <a:spAutoFit/>
+          </a:bodyPr>
+          <a:lstStyle/>
+          <a:p>
+            <a:pPr>
+              <a:defRPr sz="2200" b="1">
+                <a:solidFill>
+                  <a:srgbClr val="1E3A8A"/>
+                </a:solidFill>
+              </a:defRPr>
+            </a:pPr>
+            <a:r>
+              <a:t>Thiết Kế Kho Dữ Liệu: Lược Đồ Hình Sao (Star Schema ERD)</a:t>
+            </a:r>
+          </a:p>
+        </p:txBody>
+      </p:sp>
+      <p:pic>
+        <p:nvPicPr>
+          <p:cNvPr id="4" name="Picture 3" descr="star_schema_diagram.png"/>
+          <p:cNvPicPr>
+            <a:picLocks noChangeAspect="1"/>
+          </p:cNvPicPr>
+          <p:nvPr/>
+        </p:nvPicPr>
+        <p:blipFill>
+          <a:blip r:embed="rId2"/>
+          <a:stretch>
+            <a:fillRect/>
+          </a:stretch>
+        </p:blipFill>
+        <p:spPr>
+          <a:xfrm>
+            <a:off x="731520" y="1463040"/>
+            <a:ext cx="7863840" cy="4754880"/>
+          </a:xfrm>
+          <a:prstGeom prst="rect">
+            <a:avLst/>
+          </a:prstGeom>
+        </p:spPr>
+      </p:pic>
+      <p:sp>
+        <p:nvSpPr>
+          <p:cNvPr id="5" name="Rounded Rectangle 4"/>
+          <p:cNvSpPr/>
+          <p:nvPr/>
+        </p:nvSpPr>
+        <p:spPr>
+          <a:xfrm>
+            <a:off x="8778240" y="1463040"/>
+            <a:ext cx="2743200" cy="4754880"/>
+          </a:xfrm>
+          <a:prstGeom prst="roundRect">
+            <a:avLst/>
+          </a:prstGeom>
+          <a:solidFill>
+            <a:srgbClr val="F8FAFC"/>
+          </a:solidFill>
+          <a:ln w="12700">
+            <a:solidFill>
+              <a:srgbClr val="E2E8F0"/>
+            </a:solidFill>
+          </a:ln>
+        </p:spPr>
+        <p:style>
+          <a:lnRef idx="1">
+            <a:schemeClr val="accent1"/>
+          </a:lnRef>
+          <a:fillRef idx="3">
+            <a:schemeClr val="accent1"/>
+          </a:fillRef>
+          <a:effectRef idx="2">
+            <a:schemeClr val="accent1"/>
+          </a:effectRef>
+          <a:fontRef idx="minor">
+            <a:schemeClr val="lt1"/>
+          </a:fontRef>
+        </p:style>
+        <p:txBody>
+          <a:bodyPr rtlCol="0" anchor="ctr" wrap="square" lIns="182880" rIns="182880" tIns="182880" bIns="182880"/>
+          <a:lstStyle/>
+          <a:p>
+            <a:pPr algn="ctr">
+              <a:spcAft>
+                <a:spcPts val="600"/>
+              </a:spcAft>
+              <a:defRPr sz="1300" b="1">
+                <a:solidFill>
+                  <a:srgbClr val="1E3A8A"/>
+                </a:solidFill>
+              </a:defRPr>
+            </a:pPr>
+            <a:r>
+              <a:t>⭐ Đặc Tả Lược Đồ</a:t>
+            </a:r>
+          </a:p>
+          <a:p>
+            <a:pPr>
+              <a:spcAft>
+                <a:spcPts val="400"/>
+              </a:spcAft>
+              <a:defRPr sz="1050">
+                <a:solidFill>
+                  <a:srgbClr val="0F172A"/>
+                </a:solidFill>
+              </a:defRPr>
+            </a:pPr>
+            <a:r>
+              <a:t>• Fact: dw.FactRating</a:t>
+            </a:r>
+          </a:p>
+          <a:p>
+            <a:pPr>
+              <a:spcAft>
+                <a:spcPts val="400"/>
+              </a:spcAft>
+              <a:defRPr sz="1050">
+                <a:solidFill>
+                  <a:srgbClr val="0F172A"/>
+                </a:solidFill>
+              </a:defRPr>
+            </a:pPr>
+            <a:r>
+              <a:t>• • 1,000,209 dòng rating.</a:t>
+            </a:r>
+          </a:p>
+          <a:p>
+            <a:pPr>
+              <a:spcAft>
+                <a:spcPts val="400"/>
+              </a:spcAft>
+              <a:defRPr sz="1050">
+                <a:solidFill>
+                  <a:srgbClr val="0F172A"/>
+                </a:solidFill>
+              </a:defRPr>
+            </a:pPr>
+            <a:r>
+              <a:t>• • Grain: 1 sự kiện đánh giá.</a:t>
+            </a:r>
+          </a:p>
+          <a:p>
+            <a:pPr>
+              <a:spcAft>
+                <a:spcPts val="400"/>
+              </a:spcAft>
+              <a:defRPr sz="1050">
+                <a:solidFill>
+                  <a:srgbClr val="0F172A"/>
+                </a:solidFill>
+              </a:defRPr>
+            </a:pPr>
+            <a:r>
+              <a:t>• • Measures: rating, watch_minutes.</a:t>
+            </a:r>
+          </a:p>
+          <a:p>
+            <a:pPr>
+              <a:spcAft>
+                <a:spcPts val="400"/>
+              </a:spcAft>
+              <a:defRPr sz="1050">
+                <a:solidFill>
+                  <a:srgbClr val="0F172A"/>
+                </a:solidFill>
+              </a:defRPr>
+            </a:pPr>
+            <a:r>
+              <a:t>• 5 Dimension Tables:</a:t>
+            </a:r>
+          </a:p>
+          <a:p>
+            <a:pPr>
+              <a:spcAft>
+                <a:spcPts val="400"/>
+              </a:spcAft>
+              <a:defRPr sz="1050">
+                <a:solidFill>
+                  <a:srgbClr val="0F172A"/>
+                </a:solidFill>
+              </a:defRPr>
+            </a:pPr>
+            <a:r>
+              <a:t>• • DimUser (6,040 người dùng).</a:t>
+            </a:r>
+          </a:p>
+          <a:p>
+            <a:pPr>
+              <a:spcAft>
+                <a:spcPts val="400"/>
+              </a:spcAft>
+              <a:defRPr sz="1050">
+                <a:solidFill>
+                  <a:srgbClr val="0F172A"/>
+                </a:solidFill>
+              </a:defRPr>
+            </a:pPr>
+            <a:r>
+              <a:t>• • DimMovie (3,883 bộ phim).</a:t>
+            </a:r>
+          </a:p>
+          <a:p>
+            <a:pPr>
+              <a:spcAft>
+                <a:spcPts val="400"/>
+              </a:spcAft>
+              <a:defRPr sz="1050">
+                <a:solidFill>
+                  <a:srgbClr val="0F172A"/>
+                </a:solidFill>
+              </a:defRPr>
+            </a:pPr>
+            <a:r>
+              <a:t>• • DimDate (1,040 ngày).</a:t>
+            </a:r>
+          </a:p>
+          <a:p>
+            <a:pPr>
+              <a:spcAft>
+                <a:spcPts val="400"/>
+              </a:spcAft>
+              <a:defRPr sz="1050">
+                <a:solidFill>
+                  <a:srgbClr val="0F172A"/>
+                </a:solidFill>
+              </a:defRPr>
+            </a:pPr>
+            <a:r>
+              <a:t>• • DimDirector (1,775 đạo diễn).</a:t>
+            </a:r>
+          </a:p>
+          <a:p>
+            <a:pPr>
+              <a:spcAft>
+                <a:spcPts val="400"/>
+              </a:spcAft>
+              <a:defRPr sz="1050">
+                <a:solidFill>
+                  <a:srgbClr val="0F172A"/>
+                </a:solidFill>
+              </a:defRPr>
+            </a:pPr>
+            <a:r>
+              <a:t>• • DimGenre (18 thể loại).</a:t>
+            </a:r>
+          </a:p>
+          <a:p>
+            <a:pPr>
+              <a:spcAft>
+                <a:spcPts val="400"/>
+              </a:spcAft>
+              <a:defRPr sz="1050">
+                <a:solidFill>
+                  <a:srgbClr val="0F172A"/>
+                </a:solidFill>
+              </a:defRPr>
+            </a:pPr>
+            <a:r>
+              <a:t>• Bảng Cầu Nối Bridge:</a:t>
+            </a:r>
+          </a:p>
+          <a:p>
+            <a:pPr>
+              <a:spcAft>
+                <a:spcPts val="400"/>
+              </a:spcAft>
+              <a:defRPr sz="1050">
+                <a:solidFill>
+                  <a:srgbClr val="0F172A"/>
+                </a:solidFill>
+              </a:defRPr>
+            </a:pPr>
+            <a:r>
+              <a:t>• • BridgeMovieGenre (6,408 dòng) giải quyết quan hệ N-N.</a:t>
+            </a:r>
+          </a:p>
+        </p:txBody>
+      </p:sp>
+    </p:spTree>
+  </p:cSld>
+  <p:clrMapOvr>
+    <a:masterClrMapping/>
+  </p:clrMapOvr>
+</p:sld>
+</file>
+
+<file path=ppt/slides/slide6.xml><?xml version="1.0" encoding="utf-8"?>
 <p:sld xmlns:a="http://schemas.openxmlformats.org/drawingml/2006/main" xmlns:p="http://schemas.openxmlformats.org/presentationml/2006/main" xmlns:r="http://schemas.openxmlformats.org/officeDocument/2006/relationships">
   <p:cSld>
     <p:spTree>
@@ -7416,491 +9276,7 @@
 </p:sld>
 </file>
 
-<file path=ppt/slides/slide4.xml><?xml version="1.0" encoding="utf-8"?>
-<p:sld xmlns:a="http://schemas.openxmlformats.org/drawingml/2006/main" xmlns:p="http://schemas.openxmlformats.org/presentationml/2006/main" xmlns:r="http://schemas.openxmlformats.org/officeDocument/2006/relationships">
-  <p:cSld>
-    <p:spTree>
-      <p:nvGrpSpPr>
-        <p:cNvPr id="1" name=""/>
-        <p:cNvGrpSpPr/>
-        <p:nvPr/>
-      </p:nvGrpSpPr>
-      <p:grpSpPr/>
-      <p:sp>
-        <p:nvSpPr>
-          <p:cNvPr id="2" name="TextBox 1"/>
-          <p:cNvSpPr txBox="1"/>
-          <p:nvPr/>
-        </p:nvSpPr>
-        <p:spPr>
-          <a:xfrm>
-            <a:off x="731520" y="365760"/>
-            <a:ext cx="10058400" cy="274320"/>
-          </a:xfrm>
-          <a:prstGeom prst="rect">
-            <a:avLst/>
-          </a:prstGeom>
-          <a:noFill/>
-        </p:spPr>
-        <p:txBody>
-          <a:bodyPr wrap="square">
-            <a:spAutoFit/>
-          </a:bodyPr>
-          <a:lstStyle/>
-          <a:p>
-            <a:pPr>
-              <a:defRPr sz="900" b="1">
-                <a:solidFill>
-                  <a:srgbClr val="2563EB"/>
-                </a:solidFill>
-              </a:defRPr>
-            </a:pPr>
-            <a:r>
-              <a:t>KHO DỮ LIỆU &amp; KHAI PHÁ DỮ LIỆU • PTIT</a:t>
-            </a:r>
-          </a:p>
-        </p:txBody>
-      </p:sp>
-      <p:sp>
-        <p:nvSpPr>
-          <p:cNvPr id="3" name="TextBox 2"/>
-          <p:cNvSpPr txBox="1"/>
-          <p:nvPr/>
-        </p:nvSpPr>
-        <p:spPr>
-          <a:xfrm>
-            <a:off x="731520" y="594360"/>
-            <a:ext cx="10515600" cy="731520"/>
-          </a:xfrm>
-          <a:prstGeom prst="rect">
-            <a:avLst/>
-          </a:prstGeom>
-          <a:noFill/>
-        </p:spPr>
-        <p:txBody>
-          <a:bodyPr wrap="square">
-            <a:spAutoFit/>
-          </a:bodyPr>
-          <a:lstStyle/>
-          <a:p>
-            <a:pPr>
-              <a:defRPr sz="2200" b="1">
-                <a:solidFill>
-                  <a:srgbClr val="1E3A8A"/>
-                </a:solidFill>
-              </a:defRPr>
-            </a:pPr>
-            <a:r>
-              <a:t>Thiết Kế Kho Dữ Liệu: Lược Đồ Hình Sao (Star Schema)</a:t>
-            </a:r>
-          </a:p>
-        </p:txBody>
-      </p:sp>
-      <p:sp>
-        <p:nvSpPr>
-          <p:cNvPr id="4" name="Rounded Rectangle 3"/>
-          <p:cNvSpPr/>
-          <p:nvPr/>
-        </p:nvSpPr>
-        <p:spPr>
-          <a:xfrm>
-            <a:off x="731520" y="1645920"/>
-            <a:ext cx="3291840" cy="4389120"/>
-          </a:xfrm>
-          <a:prstGeom prst="roundRect">
-            <a:avLst/>
-          </a:prstGeom>
-          <a:solidFill>
-            <a:srgbClr val="F8FAFC"/>
-          </a:solidFill>
-          <a:ln w="12700">
-            <a:solidFill>
-              <a:srgbClr val="E2E8F0"/>
-            </a:solidFill>
-          </a:ln>
-        </p:spPr>
-        <p:style>
-          <a:lnRef idx="1">
-            <a:schemeClr val="accent1"/>
-          </a:lnRef>
-          <a:fillRef idx="3">
-            <a:schemeClr val="accent1"/>
-          </a:fillRef>
-          <a:effectRef idx="2">
-            <a:schemeClr val="accent1"/>
-          </a:effectRef>
-          <a:fontRef idx="minor">
-            <a:schemeClr val="lt1"/>
-          </a:fontRef>
-        </p:style>
-        <p:txBody>
-          <a:bodyPr rtlCol="0" anchor="ctr" wrap="square" lIns="182880" rIns="182880" tIns="182880" bIns="182880"/>
-          <a:lstStyle/>
-          <a:p>
-            <a:pPr algn="ctr">
-              <a:spcAft>
-                <a:spcPts val="600"/>
-              </a:spcAft>
-              <a:defRPr sz="1300" b="1">
-                <a:solidFill>
-                  <a:srgbClr val="1E3A8A"/>
-                </a:solidFill>
-              </a:defRPr>
-            </a:pPr>
-            <a:r>
-              <a:t>⭐ Fact Table: FactRating</a:t>
-            </a:r>
-          </a:p>
-          <a:p>
-            <a:pPr>
-              <a:spcAft>
-                <a:spcPts val="400"/>
-              </a:spcAft>
-              <a:defRPr sz="1050">
-                <a:solidFill>
-                  <a:srgbClr val="0F172A"/>
-                </a:solidFill>
-              </a:defRPr>
-            </a:pPr>
-            <a:r>
-              <a:t>• Mức độ chi tiết (Grain): 1 sự kiện đánh giá của 1 user cho 1 movie tại 1 ngày.</a:t>
-            </a:r>
-          </a:p>
-          <a:p>
-            <a:pPr>
-              <a:spcAft>
-                <a:spcPts val="400"/>
-              </a:spcAft>
-              <a:defRPr sz="1050">
-                <a:solidFill>
-                  <a:srgbClr val="0F172A"/>
-                </a:solidFill>
-              </a:defRPr>
-            </a:pPr>
-            <a:r>
-              <a:t>• Quy mô: 1,000,209 bản ghi.</a:t>
-            </a:r>
-          </a:p>
-          <a:p>
-            <a:pPr>
-              <a:spcAft>
-                <a:spcPts val="400"/>
-              </a:spcAft>
-              <a:defRPr sz="1050">
-                <a:solidFill>
-                  <a:srgbClr val="0F172A"/>
-                </a:solidFill>
-              </a:defRPr>
-            </a:pPr>
-            <a:r>
-              <a:t>• Khóa ngoại: user_key, movie_key, date_key.</a:t>
-            </a:r>
-          </a:p>
-          <a:p>
-            <a:pPr>
-              <a:spcAft>
-                <a:spcPts val="400"/>
-              </a:spcAft>
-              <a:defRPr sz="1050">
-                <a:solidFill>
-                  <a:srgbClr val="0F172A"/>
-                </a:solidFill>
-              </a:defRPr>
-            </a:pPr>
-            <a:r>
-              <a:t>• Độ đo (Measures): rating (1-5 sao), watch_minutes (thời gian xem).</a:t>
-            </a:r>
-          </a:p>
-          <a:p>
-            <a:pPr>
-              <a:spcAft>
-                <a:spcPts val="400"/>
-              </a:spcAft>
-              <a:defRPr sz="1050">
-                <a:solidFill>
-                  <a:srgbClr val="0F172A"/>
-                </a:solidFill>
-              </a:defRPr>
-            </a:pPr>
-            <a:r>
-              <a:t>• Cờ metadata: is_simulated = 1.</a:t>
-            </a:r>
-          </a:p>
-        </p:txBody>
-      </p:sp>
-      <p:sp>
-        <p:nvSpPr>
-          <p:cNvPr id="5" name="Rounded Rectangle 4"/>
-          <p:cNvSpPr/>
-          <p:nvPr/>
-        </p:nvSpPr>
-        <p:spPr>
-          <a:xfrm>
-            <a:off x="4389120" y="1645920"/>
-            <a:ext cx="3291840" cy="4389120"/>
-          </a:xfrm>
-          <a:prstGeom prst="roundRect">
-            <a:avLst/>
-          </a:prstGeom>
-          <a:solidFill>
-            <a:srgbClr val="F8FAFC"/>
-          </a:solidFill>
-          <a:ln w="12700">
-            <a:solidFill>
-              <a:srgbClr val="E2E8F0"/>
-            </a:solidFill>
-          </a:ln>
-        </p:spPr>
-        <p:style>
-          <a:lnRef idx="1">
-            <a:schemeClr val="accent1"/>
-          </a:lnRef>
-          <a:fillRef idx="3">
-            <a:schemeClr val="accent1"/>
-          </a:fillRef>
-          <a:effectRef idx="2">
-            <a:schemeClr val="accent1"/>
-          </a:effectRef>
-          <a:fontRef idx="minor">
-            <a:schemeClr val="lt1"/>
-          </a:fontRef>
-        </p:style>
-        <p:txBody>
-          <a:bodyPr rtlCol="0" anchor="ctr" wrap="square" lIns="182880" rIns="182880" tIns="182880" bIns="182880"/>
-          <a:lstStyle/>
-          <a:p>
-            <a:pPr algn="ctr">
-              <a:spcAft>
-                <a:spcPts val="600"/>
-              </a:spcAft>
-              <a:defRPr sz="1300" b="1">
-                <a:solidFill>
-                  <a:srgbClr val="1E3A8A"/>
-                </a:solidFill>
-              </a:defRPr>
-            </a:pPr>
-            <a:r>
-              <a:t>📊 5 Dimension Tables</a:t>
-            </a:r>
-          </a:p>
-          <a:p>
-            <a:pPr>
-              <a:spcAft>
-                <a:spcPts val="400"/>
-              </a:spcAft>
-              <a:defRPr sz="1050">
-                <a:solidFill>
-                  <a:srgbClr val="0F172A"/>
-                </a:solidFill>
-              </a:defRPr>
-            </a:pPr>
-            <a:r>
-              <a:t>• DimUser: 6,040 người dùng (gender, age_group, occupation).</a:t>
-            </a:r>
-          </a:p>
-          <a:p>
-            <a:pPr>
-              <a:spcAft>
-                <a:spcPts val="400"/>
-              </a:spcAft>
-              <a:defRPr sz="1050">
-                <a:solidFill>
-                  <a:srgbClr val="0F172A"/>
-                </a:solidFill>
-              </a:defRPr>
-            </a:pPr>
-            <a:r>
-              <a:t>• DimMovie: 3,883 bộ phim (title, release_year, runtime, imdb_id).</a:t>
-            </a:r>
-          </a:p>
-          <a:p>
-            <a:pPr>
-              <a:spcAft>
-                <a:spcPts val="400"/>
-              </a:spcAft>
-              <a:defRPr sz="1050">
-                <a:solidFill>
-                  <a:srgbClr val="0F172A"/>
-                </a:solidFill>
-              </a:defRPr>
-            </a:pPr>
-            <a:r>
-              <a:t>• DimDirector: 1,775 đạo diễn định danh từ IMDb.</a:t>
-            </a:r>
-          </a:p>
-          <a:p>
-            <a:pPr>
-              <a:spcAft>
-                <a:spcPts val="400"/>
-              </a:spcAft>
-              <a:defRPr sz="1050">
-                <a:solidFill>
-                  <a:srgbClr val="0F172A"/>
-                </a:solidFill>
-              </a:defRPr>
-            </a:pPr>
-            <a:r>
-              <a:t>• DimGenre: 18 thể loại chuẩn hóa.</a:t>
-            </a:r>
-          </a:p>
-          <a:p>
-            <a:pPr>
-              <a:spcAft>
-                <a:spcPts val="400"/>
-              </a:spcAft>
-              <a:defRPr sz="1050">
-                <a:solidFill>
-                  <a:srgbClr val="0F172A"/>
-                </a:solidFill>
-              </a:defRPr>
-            </a:pPr>
-            <a:r>
-              <a:t>• DimDate: 1,040 ngày (Year, Quarter, Month, Day, DayOfWeek, Weekend).</a:t>
-            </a:r>
-          </a:p>
-        </p:txBody>
-      </p:sp>
-      <p:sp>
-        <p:nvSpPr>
-          <p:cNvPr id="6" name="Rounded Rectangle 5"/>
-          <p:cNvSpPr/>
-          <p:nvPr/>
-        </p:nvSpPr>
-        <p:spPr>
-          <a:xfrm>
-            <a:off x="8046720" y="1645920"/>
-            <a:ext cx="3291840" cy="4389120"/>
-          </a:xfrm>
-          <a:prstGeom prst="roundRect">
-            <a:avLst/>
-          </a:prstGeom>
-          <a:solidFill>
-            <a:srgbClr val="F8FAFC"/>
-          </a:solidFill>
-          <a:ln w="12700">
-            <a:solidFill>
-              <a:srgbClr val="E2E8F0"/>
-            </a:solidFill>
-          </a:ln>
-        </p:spPr>
-        <p:style>
-          <a:lnRef idx="1">
-            <a:schemeClr val="accent1"/>
-          </a:lnRef>
-          <a:fillRef idx="3">
-            <a:schemeClr val="accent1"/>
-          </a:fillRef>
-          <a:effectRef idx="2">
-            <a:schemeClr val="accent1"/>
-          </a:effectRef>
-          <a:fontRef idx="minor">
-            <a:schemeClr val="lt1"/>
-          </a:fontRef>
-        </p:style>
-        <p:txBody>
-          <a:bodyPr rtlCol="0" anchor="ctr" wrap="square" lIns="182880" rIns="182880" tIns="182880" bIns="182880"/>
-          <a:lstStyle/>
-          <a:p>
-            <a:pPr algn="ctr">
-              <a:spcAft>
-                <a:spcPts val="600"/>
-              </a:spcAft>
-              <a:defRPr sz="1300" b="1">
-                <a:solidFill>
-                  <a:srgbClr val="1E3A8A"/>
-                </a:solidFill>
-              </a:defRPr>
-            </a:pPr>
-            <a:r>
-              <a:t>🌉 Bridge Table &amp; Indexing</a:t>
-            </a:r>
-          </a:p>
-          <a:p>
-            <a:pPr>
-              <a:spcAft>
-                <a:spcPts val="400"/>
-              </a:spcAft>
-              <a:defRPr sz="1050">
-                <a:solidFill>
-                  <a:srgbClr val="0F172A"/>
-                </a:solidFill>
-              </a:defRPr>
-            </a:pPr>
-            <a:r>
-              <a:t>• BridgeMovieGenre: 6,408 liên kết xử lý quan hệ nhiều-nhiều (N:N).</a:t>
-            </a:r>
-          </a:p>
-          <a:p>
-            <a:pPr>
-              <a:spcAft>
-                <a:spcPts val="400"/>
-              </a:spcAft>
-              <a:defRPr sz="1050">
-                <a:solidFill>
-                  <a:srgbClr val="0F172A"/>
-                </a:solidFill>
-              </a:defRPr>
-            </a:pPr>
-            <a:r>
-              <a:t>• Indexing tối ưu hóa OLAP:</a:t>
-            </a:r>
-          </a:p>
-          <a:p>
-            <a:pPr>
-              <a:spcAft>
-                <a:spcPts val="400"/>
-              </a:spcAft>
-              <a:defRPr sz="1050">
-                <a:solidFill>
-                  <a:srgbClr val="0F172A"/>
-                </a:solidFill>
-              </a:defRPr>
-            </a:pPr>
-            <a:r>
-              <a:t>• - Non-clustered index trên user_key, movie_key, date_key (có INCLUDE measures).</a:t>
-            </a:r>
-          </a:p>
-          <a:p>
-            <a:pPr>
-              <a:spcAft>
-                <a:spcPts val="400"/>
-              </a:spcAft>
-              <a:defRPr sz="1050">
-                <a:solidFill>
-                  <a:srgbClr val="0F172A"/>
-                </a:solidFill>
-              </a:defRPr>
-            </a:pPr>
-            <a:r>
-              <a:t>• - Index trên BridgeMovieGenre(genre_key, movie_key).</a:t>
-            </a:r>
-          </a:p>
-          <a:p>
-            <a:pPr>
-              <a:spcAft>
-                <a:spcPts val="400"/>
-              </a:spcAft>
-              <a:defRPr sz="1050">
-                <a:solidFill>
-                  <a:srgbClr val="0F172A"/>
-                </a:solidFill>
-              </a:defRPr>
-            </a:pPr>
-            <a:r>
-              <a:t>• - Index trên DimDate(year, quarter).</a:t>
-            </a:r>
-          </a:p>
-        </p:txBody>
-      </p:sp>
-    </p:spTree>
-  </p:cSld>
-  <p:clrMapOvr>
-    <a:masterClrMapping/>
-  </p:clrMapOvr>
-</p:sld>
-</file>
-
-<file path=ppt/slides/slide5.xml><?xml version="1.0" encoding="utf-8"?>
+<file path=ppt/slides/slide7.xml><?xml version="1.0" encoding="utf-8"?>
 <p:sld xmlns:a="http://schemas.openxmlformats.org/drawingml/2006/main" xmlns:p="http://schemas.openxmlformats.org/presentationml/2006/main" xmlns:r="http://schemas.openxmlformats.org/officeDocument/2006/relationships">
   <p:cSld>
     <p:spTree>
@@ -8267,7 +9643,7 @@
 </p:sld>
 </file>
 
-<file path=ppt/slides/slide6.xml><?xml version="1.0" encoding="utf-8"?>
+<file path=ppt/slides/slide8.xml><?xml version="1.0" encoding="utf-8"?>
 <p:sld xmlns:a="http://schemas.openxmlformats.org/drawingml/2006/main" xmlns:p="http://schemas.openxmlformats.org/presentationml/2006/main" xmlns:r="http://schemas.openxmlformats.org/officeDocument/2006/relationships">
   <p:cSld>
     <p:spTree>
@@ -8556,7 +9932,7 @@
 </p:sld>
 </file>
 
-<file path=ppt/slides/slide7.xml><?xml version="1.0" encoding="utf-8"?>
+<file path=ppt/slides/slide9.xml><?xml version="1.0" encoding="utf-8"?>
 <p:sld xmlns:a="http://schemas.openxmlformats.org/drawingml/2006/main" xmlns:p="http://schemas.openxmlformats.org/presentationml/2006/main" xmlns:r="http://schemas.openxmlformats.org/officeDocument/2006/relationships">
   <p:cSld>
     <p:spTree>
@@ -9101,554 +10477,6 @@
           </a:p>
         </p:txBody>
       </p:sp>
-    </p:spTree>
-  </p:cSld>
-  <p:clrMapOvr>
-    <a:masterClrMapping/>
-  </p:clrMapOvr>
-</p:sld>
-</file>
-
-<file path=ppt/slides/slide8.xml><?xml version="1.0" encoding="utf-8"?>
-<p:sld xmlns:a="http://schemas.openxmlformats.org/drawingml/2006/main" xmlns:p="http://schemas.openxmlformats.org/presentationml/2006/main" xmlns:r="http://schemas.openxmlformats.org/officeDocument/2006/relationships">
-  <p:cSld>
-    <p:spTree>
-      <p:nvGrpSpPr>
-        <p:cNvPr id="1" name=""/>
-        <p:cNvGrpSpPr/>
-        <p:nvPr/>
-      </p:nvGrpSpPr>
-      <p:grpSpPr/>
-      <p:sp>
-        <p:nvSpPr>
-          <p:cNvPr id="2" name="TextBox 1"/>
-          <p:cNvSpPr txBox="1"/>
-          <p:nvPr/>
-        </p:nvSpPr>
-        <p:spPr>
-          <a:xfrm>
-            <a:off x="731520" y="365760"/>
-            <a:ext cx="10058400" cy="274320"/>
-          </a:xfrm>
-          <a:prstGeom prst="rect">
-            <a:avLst/>
-          </a:prstGeom>
-          <a:noFill/>
-        </p:spPr>
-        <p:txBody>
-          <a:bodyPr wrap="square">
-            <a:spAutoFit/>
-          </a:bodyPr>
-          <a:lstStyle/>
-          <a:p>
-            <a:pPr>
-              <a:defRPr sz="900" b="1">
-                <a:solidFill>
-                  <a:srgbClr val="2563EB"/>
-                </a:solidFill>
-              </a:defRPr>
-            </a:pPr>
-            <a:r>
-              <a:t>KHO DỮ LIỆU &amp; KHAI PHÁ DỮ LIỆU • PTIT</a:t>
-            </a:r>
-          </a:p>
-        </p:txBody>
-      </p:sp>
-      <p:sp>
-        <p:nvSpPr>
-          <p:cNvPr id="3" name="TextBox 2"/>
-          <p:cNvSpPr txBox="1"/>
-          <p:nvPr/>
-        </p:nvSpPr>
-        <p:spPr>
-          <a:xfrm>
-            <a:off x="731520" y="594360"/>
-            <a:ext cx="10515600" cy="731520"/>
-          </a:xfrm>
-          <a:prstGeom prst="rect">
-            <a:avLst/>
-          </a:prstGeom>
-          <a:noFill/>
-        </p:spPr>
-        <p:txBody>
-          <a:bodyPr wrap="square">
-            <a:spAutoFit/>
-          </a:bodyPr>
-          <a:lstStyle/>
-          <a:p>
-            <a:pPr>
-              <a:defRPr sz="2200" b="1">
-                <a:solidFill>
-                  <a:srgbClr val="1E3A8A"/>
-                </a:solidFill>
-              </a:defRPr>
-            </a:pPr>
-            <a:r>
-              <a:t>Khai Phá Phân Cụm Người Dùng Bằng K-Means &amp; PCA (Q1)</a:t>
-            </a:r>
-          </a:p>
-        </p:txBody>
-      </p:sp>
-      <p:sp>
-        <p:nvSpPr>
-          <p:cNvPr id="4" name="Rounded Rectangle 3"/>
-          <p:cNvSpPr/>
-          <p:nvPr/>
-        </p:nvSpPr>
-        <p:spPr>
-          <a:xfrm>
-            <a:off x="731520" y="1645920"/>
-            <a:ext cx="4937760" cy="4389120"/>
-          </a:xfrm>
-          <a:prstGeom prst="roundRect">
-            <a:avLst/>
-          </a:prstGeom>
-          <a:solidFill>
-            <a:srgbClr val="F8FAFC"/>
-          </a:solidFill>
-          <a:ln w="12700">
-            <a:solidFill>
-              <a:srgbClr val="E2E8F0"/>
-            </a:solidFill>
-          </a:ln>
-        </p:spPr>
-        <p:style>
-          <a:lnRef idx="1">
-            <a:schemeClr val="accent1"/>
-          </a:lnRef>
-          <a:fillRef idx="3">
-            <a:schemeClr val="accent1"/>
-          </a:fillRef>
-          <a:effectRef idx="2">
-            <a:schemeClr val="accent1"/>
-          </a:effectRef>
-          <a:fontRef idx="minor">
-            <a:schemeClr val="lt1"/>
-          </a:fontRef>
-        </p:style>
-        <p:txBody>
-          <a:bodyPr rtlCol="0" anchor="ctr" wrap="square" lIns="182880" rIns="182880" tIns="182880" bIns="182880"/>
-          <a:lstStyle/>
-          <a:p>
-            <a:pPr algn="ctr">
-              <a:spcAft>
-                <a:spcPts val="600"/>
-              </a:spcAft>
-              <a:defRPr sz="1300" b="1">
-                <a:solidFill>
-                  <a:srgbClr val="1E3A8A"/>
-                </a:solidFill>
-              </a:defRPr>
-            </a:pPr>
-            <a:r>
-              <a:t>👥 Chân Dung 4 Cụm Thị Hiếu Khán Giả</a:t>
-            </a:r>
-          </a:p>
-          <a:p>
-            <a:pPr>
-              <a:spcAft>
-                <a:spcPts val="400"/>
-              </a:spcAft>
-              <a:defRPr sz="1050">
-                <a:solidFill>
-                  <a:srgbClr val="0F172A"/>
-                </a:solidFill>
-              </a:defRPr>
-            </a:pPr>
-            <a:r>
-              <a:t>• Xác định K=4 tối ưu qua Elbow (SSE) &amp; Silhouette.</a:t>
-            </a:r>
-          </a:p>
-          <a:p>
-            <a:pPr>
-              <a:spcAft>
-                <a:spcPts val="400"/>
-              </a:spcAft>
-              <a:defRPr sz="1050">
-                <a:solidFill>
-                  <a:srgbClr val="0F172A"/>
-                </a:solidFill>
-              </a:defRPr>
-            </a:pPr>
-            <a:r>
-              <a:t>• Cụm 0 (26.1% - 1,579 users): Tín đồ Hành động &amp; Sci-Fi (Action 18.3%, Sci-Fi 12.6%).</a:t>
-            </a:r>
-          </a:p>
-          <a:p>
-            <a:pPr>
-              <a:spcAft>
-                <a:spcPts val="400"/>
-              </a:spcAft>
-              <a:defRPr sz="1050">
-                <a:solidFill>
-                  <a:srgbClr val="0F172A"/>
-                </a:solidFill>
-              </a:defRPr>
-            </a:pPr>
-            <a:r>
-              <a:t>• Cụm 1 (36.0% - 2,177 users): Khán giả Tâm lý &amp; Lãng mạn (Drama 24.0%, Romance 8.7%).</a:t>
-            </a:r>
-          </a:p>
-          <a:p>
-            <a:pPr>
-              <a:spcAft>
-                <a:spcPts val="400"/>
-              </a:spcAft>
-              <a:defRPr sz="1050">
-                <a:solidFill>
-                  <a:srgbClr val="0F172A"/>
-                </a:solidFill>
-              </a:defRPr>
-            </a:pPr>
-            <a:r>
-              <a:t>• Cụm 2 (31.2% - 1,882 users): Khán giả Giải trí Đại chúng (Comedy 18.9%, Drama 18.0%).</a:t>
-            </a:r>
-          </a:p>
-          <a:p>
-            <a:pPr>
-              <a:spcAft>
-                <a:spcPts val="400"/>
-              </a:spcAft>
-              <a:defRPr sz="1050">
-                <a:solidFill>
-                  <a:srgbClr val="0F172A"/>
-                </a:solidFill>
-              </a:defRPr>
-            </a:pPr>
-            <a:r>
-              <a:t>• Cụm 3 (6.7% - 402 users): Khán giả Gia đình &amp; Thiếu nhi (Comedy 19.4%, Children's 11.9%).</a:t>
-            </a:r>
-          </a:p>
-        </p:txBody>
-      </p:sp>
-      <p:pic>
-        <p:nvPicPr>
-          <p:cNvPr id="5" name="Picture 4" descr="kmeans_clusters_pca.png"/>
-          <p:cNvPicPr>
-            <a:picLocks noChangeAspect="1"/>
-          </p:cNvPicPr>
-          <p:nvPr/>
-        </p:nvPicPr>
-        <p:blipFill>
-          <a:blip r:embed="rId2"/>
-          <a:stretch>
-            <a:fillRect/>
-          </a:stretch>
-        </p:blipFill>
-        <p:spPr>
-          <a:xfrm>
-            <a:off x="5943600" y="1645920"/>
-            <a:ext cx="5486400" cy="3840480"/>
-          </a:xfrm>
-          <a:prstGeom prst="rect">
-            <a:avLst/>
-          </a:prstGeom>
-        </p:spPr>
-      </p:pic>
-    </p:spTree>
-  </p:cSld>
-  <p:clrMapOvr>
-    <a:masterClrMapping/>
-  </p:clrMapOvr>
-</p:sld>
-</file>
-
-<file path=ppt/slides/slide9.xml><?xml version="1.0" encoding="utf-8"?>
-<p:sld xmlns:a="http://schemas.openxmlformats.org/drawingml/2006/main" xmlns:p="http://schemas.openxmlformats.org/presentationml/2006/main" xmlns:r="http://schemas.openxmlformats.org/officeDocument/2006/relationships">
-  <p:cSld>
-    <p:spTree>
-      <p:nvGrpSpPr>
-        <p:cNvPr id="1" name=""/>
-        <p:cNvGrpSpPr/>
-        <p:nvPr/>
-      </p:nvGrpSpPr>
-      <p:grpSpPr/>
-      <p:sp>
-        <p:nvSpPr>
-          <p:cNvPr id="2" name="TextBox 1"/>
-          <p:cNvSpPr txBox="1"/>
-          <p:nvPr/>
-        </p:nvSpPr>
-        <p:spPr>
-          <a:xfrm>
-            <a:off x="731520" y="365760"/>
-            <a:ext cx="10058400" cy="274320"/>
-          </a:xfrm>
-          <a:prstGeom prst="rect">
-            <a:avLst/>
-          </a:prstGeom>
-          <a:noFill/>
-        </p:spPr>
-        <p:txBody>
-          <a:bodyPr wrap="square">
-            <a:spAutoFit/>
-          </a:bodyPr>
-          <a:lstStyle/>
-          <a:p>
-            <a:pPr>
-              <a:defRPr sz="900" b="1">
-                <a:solidFill>
-                  <a:srgbClr val="2563EB"/>
-                </a:solidFill>
-              </a:defRPr>
-            </a:pPr>
-            <a:r>
-              <a:t>KHO DỮ LIỆU &amp; KHAI PHÁ DỮ LIỆU • PTIT</a:t>
-            </a:r>
-          </a:p>
-        </p:txBody>
-      </p:sp>
-      <p:sp>
-        <p:nvSpPr>
-          <p:cNvPr id="3" name="TextBox 2"/>
-          <p:cNvSpPr txBox="1"/>
-          <p:nvPr/>
-        </p:nvSpPr>
-        <p:spPr>
-          <a:xfrm>
-            <a:off x="731520" y="594360"/>
-            <a:ext cx="10515600" cy="731520"/>
-          </a:xfrm>
-          <a:prstGeom prst="rect">
-            <a:avLst/>
-          </a:prstGeom>
-          <a:noFill/>
-        </p:spPr>
-        <p:txBody>
-          <a:bodyPr wrap="square">
-            <a:spAutoFit/>
-          </a:bodyPr>
-          <a:lstStyle/>
-          <a:p>
-            <a:pPr>
-              <a:defRPr sz="2200" b="1">
-                <a:solidFill>
-                  <a:srgbClr val="1E3A8A"/>
-                </a:solidFill>
-              </a:defRPr>
-            </a:pPr>
-            <a:r>
-              <a:t>Kiểm Định Thống Kê Chi-Square: Thị Hiếu Theo Tuổi &amp; Giới Tính (Q1)</a:t>
-            </a:r>
-          </a:p>
-        </p:txBody>
-      </p:sp>
-      <p:sp>
-        <p:nvSpPr>
-          <p:cNvPr id="4" name="Rounded Rectangle 3"/>
-          <p:cNvSpPr/>
-          <p:nvPr/>
-        </p:nvSpPr>
-        <p:spPr>
-          <a:xfrm>
-            <a:off x="731520" y="1645920"/>
-            <a:ext cx="4937760" cy="4389120"/>
-          </a:xfrm>
-          <a:prstGeom prst="roundRect">
-            <a:avLst/>
-          </a:prstGeom>
-          <a:solidFill>
-            <a:srgbClr val="F8FAFC"/>
-          </a:solidFill>
-          <a:ln w="12700">
-            <a:solidFill>
-              <a:srgbClr val="E2E8F0"/>
-            </a:solidFill>
-          </a:ln>
-        </p:spPr>
-        <p:style>
-          <a:lnRef idx="1">
-            <a:schemeClr val="accent1"/>
-          </a:lnRef>
-          <a:fillRef idx="3">
-            <a:schemeClr val="accent1"/>
-          </a:fillRef>
-          <a:effectRef idx="2">
-            <a:schemeClr val="accent1"/>
-          </a:effectRef>
-          <a:fontRef idx="minor">
-            <a:schemeClr val="lt1"/>
-          </a:fontRef>
-        </p:style>
-        <p:txBody>
-          <a:bodyPr rtlCol="0" anchor="ctr" wrap="square" lIns="182880" rIns="182880" tIns="182880" bIns="182880"/>
-          <a:lstStyle/>
-          <a:p>
-            <a:pPr algn="ctr">
-              <a:spcAft>
-                <a:spcPts val="600"/>
-              </a:spcAft>
-              <a:defRPr sz="1300" b="1">
-                <a:solidFill>
-                  <a:srgbClr val="1E3A8A"/>
-                </a:solidFill>
-              </a:defRPr>
-            </a:pPr>
-            <a:r>
-              <a:t>🧪 Kết Quả Kiểm Định Chi-Square (p &lt; 0.001)</a:t>
-            </a:r>
-          </a:p>
-          <a:p>
-            <a:pPr>
-              <a:spcAft>
-                <a:spcPts val="400"/>
-              </a:spcAft>
-              <a:defRPr sz="1050">
-                <a:solidFill>
-                  <a:srgbClr val="0F172A"/>
-                </a:solidFill>
-              </a:defRPr>
-            </a:pPr>
-            <a:r>
-              <a:t>• 1. Phân tích Giới tính (Gender):</a:t>
-            </a:r>
-          </a:p>
-          <a:p>
-            <a:pPr>
-              <a:spcAft>
-                <a:spcPts val="400"/>
-              </a:spcAft>
-              <a:defRPr sz="1050">
-                <a:solidFill>
-                  <a:srgbClr val="0F172A"/>
-                </a:solidFill>
-              </a:defRPr>
-            </a:pPr>
-            <a:r>
-              <a:t>• - Chi2 = 358.78, p-value = 1.87e-77, DoF = 3.</a:t>
-            </a:r>
-          </a:p>
-          <a:p>
-            <a:pPr>
-              <a:spcAft>
-                <a:spcPts val="400"/>
-              </a:spcAft>
-              <a:defRPr sz="1050">
-                <a:solidFill>
-                  <a:srgbClr val="0F172A"/>
-                </a:solidFill>
-              </a:defRPr>
-            </a:pPr>
-            <a:r>
-              <a:t>• - Cụm 0 (Action/Sci-Fi): 86.26% là Nam (áp đảo).</a:t>
-            </a:r>
-          </a:p>
-          <a:p>
-            <a:pPr>
-              <a:spcAft>
-                <a:spcPts val="400"/>
-              </a:spcAft>
-              <a:defRPr sz="1050">
-                <a:solidFill>
-                  <a:srgbClr val="0F172A"/>
-                </a:solidFill>
-              </a:defRPr>
-            </a:pPr>
-            <a:r>
-              <a:t>• - Cụm 3 (Thiếu nhi/Gia đình): 54.98% là Nữ.</a:t>
-            </a:r>
-          </a:p>
-          <a:p>
-            <a:pPr>
-              <a:spcAft>
-                <a:spcPts val="400"/>
-              </a:spcAft>
-              <a:defRPr sz="1050">
-                <a:solidFill>
-                  <a:srgbClr val="0F172A"/>
-                </a:solidFill>
-              </a:defRPr>
-            </a:pPr>
-            <a:r>
-              <a:t>• 2. Phân tích Nhóm tuổi (Age Groups):</a:t>
-            </a:r>
-          </a:p>
-          <a:p>
-            <a:pPr>
-              <a:spcAft>
-                <a:spcPts val="400"/>
-              </a:spcAft>
-              <a:defRPr sz="1050">
-                <a:solidFill>
-                  <a:srgbClr val="0F172A"/>
-                </a:solidFill>
-              </a:defRPr>
-            </a:pPr>
-            <a:r>
-              <a:t>• - Chi2 = 329.21, p-value = 4.58e-59, DoF = 18.</a:t>
-            </a:r>
-          </a:p>
-          <a:p>
-            <a:pPr>
-              <a:spcAft>
-                <a:spcPts val="400"/>
-              </a:spcAft>
-              <a:defRPr sz="1050">
-                <a:solidFill>
-                  <a:srgbClr val="0F172A"/>
-                </a:solidFill>
-              </a:defRPr>
-            </a:pPr>
-            <a:r>
-              <a:t>• - Nhóm Under 18: Tập trung cao đột biến tại Cụm 3 (14.43%, gấp 5 lần cụm khác).</a:t>
-            </a:r>
-          </a:p>
-          <a:p>
-            <a:pPr>
-              <a:spcAft>
-                <a:spcPts val="400"/>
-              </a:spcAft>
-              <a:defRPr sz="1050">
-                <a:solidFill>
-                  <a:srgbClr val="0F172A"/>
-                </a:solidFill>
-              </a:defRPr>
-            </a:pPr>
-            <a:r>
-              <a:t>• - Nhóm 45+ tuổi: Chiếm 31.33% tại Cụm 1 (Tâm lý/Drama).</a:t>
-            </a:r>
-          </a:p>
-          <a:p>
-            <a:pPr>
-              <a:spcAft>
-                <a:spcPts val="400"/>
-              </a:spcAft>
-              <a:defRPr sz="1050">
-                <a:solidFill>
-                  <a:srgbClr val="0F172A"/>
-                </a:solidFill>
-              </a:defRPr>
-            </a:pPr>
-            <a:r>
-              <a:t>• =&gt; Kết luận Q1: Giới tính &amp; độ tuổi tác động cực kỳ mạnh mẽ đến gu điện ảnh.</a:t>
-            </a:r>
-          </a:p>
-        </p:txBody>
-      </p:sp>
-      <p:pic>
-        <p:nvPicPr>
-          <p:cNvPr id="5" name="Picture 4" descr="cluster_gender_distribution.png"/>
-          <p:cNvPicPr>
-            <a:picLocks noChangeAspect="1"/>
-          </p:cNvPicPr>
-          <p:nvPr/>
-        </p:nvPicPr>
-        <p:blipFill>
-          <a:blip r:embed="rId2"/>
-          <a:stretch>
-            <a:fillRect/>
-          </a:stretch>
-        </p:blipFill>
-        <p:spPr>
-          <a:xfrm>
-            <a:off x="5943600" y="1645920"/>
-            <a:ext cx="5486400" cy="3048000"/>
-          </a:xfrm>
-          <a:prstGeom prst="rect">
-            <a:avLst/>
-          </a:prstGeom>
-        </p:spPr>
-      </p:pic>
     </p:spTree>
   </p:cSld>
   <p:clrMapOvr>

</xml_diff>